<commit_message>
Fill the wireframe slide and expand the sparse ones in the submission deck
Co-Authored-By: Claude Opus 5 <noreply@anthropic.com>
</commit_message>
<xml_diff>
--- a/docs/submission/Drishti_KSP_Datathon_2026_Prototype_Submission.pptx
+++ b/docs/submission/Drishti_KSP_Datathon_2026_Prototype_Submission.pptx
@@ -3651,35 +3651,166 @@
                 <a:spcPct val="122000"/>
               </a:lnSpc>
               <a:spcAft>
+                <a:spcPts val="1000"/>
+              </a:spcAft>
+            </a:pPr>
+            <a:r>
+              <a:rPr sz="1300" b="0">
+                <a:solidFill>
+                  <a:srgbClr val="333840"/>
+                </a:solidFill>
+                <a:latin typeface="Arial"/>
+              </a:rPr>
+              <a:t>Costs stay low because the pipeline uses </a:t>
+            </a:r>
+            <a:r>
+              <a:rPr sz="1300" b="1">
+                <a:solidFill>
+                  <a:srgbClr val="333840"/>
+                </a:solidFill>
+                <a:latin typeface="Arial"/>
+              </a:rPr>
+              <a:t>CPU-based scikit-learn models — no GPUs and no external LLM API calls</a:t>
+            </a:r>
+            <a:r>
+              <a:rPr sz="1300" b="0">
+                <a:solidFill>
+                  <a:srgbClr val="333840"/>
+                </a:solidFill>
+                <a:latin typeface="Arial"/>
+              </a:rPr>
+              <a:t> — and linkage runs as a nightly batch rather than on every user query. Figures are estimates and vary with data volume and recomputation frequency.</a:t>
+            </a:r>
+          </a:p>
+          <a:p>
+            <a:pPr algn="l">
+              <a:lnSpc>
+                <a:spcPct val="122000"/>
+              </a:lnSpc>
+              <a:spcAft>
+                <a:spcPts val="500"/>
+              </a:spcAft>
+            </a:pPr>
+            <a:r>
+              <a:rPr sz="1300" b="1">
+                <a:solidFill>
+                  <a:srgbClr val="A8231B"/>
+                </a:solidFill>
+                <a:latin typeface="Arial"/>
+              </a:rPr>
+              <a:t>What is not in the cost</a:t>
+            </a:r>
+          </a:p>
+          <a:p>
+            <a:pPr algn="l">
+              <a:lnSpc>
+                <a:spcPct val="122000"/>
+              </a:lnSpc>
+              <a:spcAft>
+                <a:spcPts val="400"/>
+              </a:spcAft>
+            </a:pPr>
+            <a:r>
+              <a:rPr sz="1250" b="1">
+                <a:solidFill>
+                  <a:srgbClr val="333840"/>
+                </a:solidFill>
+                <a:latin typeface="Arial"/>
+              </a:rPr>
+              <a:t>No new data collection</a:t>
+            </a:r>
+            <a:r>
+              <a:rPr sz="1250" b="0">
+                <a:solidFill>
+                  <a:srgbClr val="333840"/>
+                </a:solidFill>
+                <a:latin typeface="Arial"/>
+              </a:rPr>
+              <a:t> — it reads the FIR schema exactly as it exists.</a:t>
+            </a:r>
+          </a:p>
+          <a:p>
+            <a:pPr algn="l">
+              <a:lnSpc>
+                <a:spcPct val="122000"/>
+              </a:lnSpc>
+              <a:spcAft>
+                <a:spcPts val="400"/>
+              </a:spcAft>
+            </a:pPr>
+            <a:r>
+              <a:rPr sz="1250" b="1">
+                <a:solidFill>
+                  <a:srgbClr val="333840"/>
+                </a:solidFill>
+                <a:latin typeface="Arial"/>
+              </a:rPr>
+              <a:t>No change to officer workflow</a:t>
+            </a:r>
+            <a:r>
+              <a:rPr sz="1250" b="0">
+                <a:solidFill>
+                  <a:srgbClr val="333840"/>
+                </a:solidFill>
+                <a:latin typeface="Arial"/>
+              </a:rPr>
+              <a:t> — no additional field, form or step when filing an FIR.</a:t>
+            </a:r>
+          </a:p>
+          <a:p>
+            <a:pPr algn="l">
+              <a:lnSpc>
+                <a:spcPct val="122000"/>
+              </a:lnSpc>
+              <a:spcAft>
+                <a:spcPts val="400"/>
+              </a:spcAft>
+            </a:pPr>
+            <a:r>
+              <a:rPr sz="1250" b="1">
+                <a:solidFill>
+                  <a:srgbClr val="333840"/>
+                </a:solidFill>
+                <a:latin typeface="Arial"/>
+              </a:rPr>
+              <a:t>No third-party licences</a:t>
+            </a:r>
+            <a:r>
+              <a:rPr sz="1250" b="0">
+                <a:solidFill>
+                  <a:srgbClr val="333840"/>
+                </a:solidFill>
+                <a:latin typeface="Arial"/>
+              </a:rPr>
+              <a:t> — every component is either open-source or a Catalyst service already in the KSP stack.</a:t>
+            </a:r>
+          </a:p>
+          <a:p>
+            <a:pPr algn="l">
+              <a:lnSpc>
+                <a:spcPct val="122000"/>
+              </a:lnSpc>
+              <a:spcAft>
                 <a:spcPts val="700"/>
               </a:spcAft>
             </a:pPr>
             <a:r>
-              <a:rPr sz="1300" b="0">
-                <a:solidFill>
-                  <a:srgbClr val="333840"/>
-                </a:solidFill>
-                <a:latin typeface="Arial"/>
-              </a:rPr>
-              <a:t>Costs stay low because the pipeline uses </a:t>
-            </a:r>
-            <a:r>
-              <a:rPr sz="1300" b="1">
-                <a:solidFill>
-                  <a:srgbClr val="333840"/>
-                </a:solidFill>
-                <a:latin typeface="Arial"/>
-              </a:rPr>
-              <a:t>CPU-based scikit-learn models — no GPUs and no external LLM API calls</a:t>
-            </a:r>
-            <a:r>
-              <a:rPr sz="1300" b="0">
-                <a:solidFill>
-                  <a:srgbClr val="333840"/>
-                </a:solidFill>
-                <a:latin typeface="Arial"/>
-              </a:rPr>
-              <a:t> — and linkage runs as a nightly batch rather than on every user query. Figures are estimates and vary with data volume and recomputation frequency.</a:t>
+              <a:rPr sz="1250" b="1">
+                <a:solidFill>
+                  <a:srgbClr val="333840"/>
+                </a:solidFill>
+                <a:latin typeface="Arial"/>
+              </a:rPr>
+              <a:t>No GPU or inference hardware</a:t>
+            </a:r>
+            <a:r>
+              <a:rPr sz="1250" b="0">
+                <a:solidFill>
+                  <a:srgbClr val="333840"/>
+                </a:solidFill>
+                <a:latin typeface="Arial"/>
+              </a:rPr>
+              <a:t>, and no per-query API spend that grows with usage.</a:t>
             </a:r>
           </a:p>
         </p:txBody>
@@ -4786,17 +4917,120 @@
                 <a:spcPct val="122000"/>
               </a:lnSpc>
               <a:spcAft>
+                <a:spcPts val="1200"/>
+              </a:spcAft>
+            </a:pPr>
+            <a:r>
+              <a:rPr sz="1250" b="0">
+                <a:solidFill>
+                  <a:srgbClr val="666C77"/>
+                </a:solidFill>
+                <a:latin typeface="Arial"/>
+              </a:rPr>
+              <a:t>Live on Zoho Catalyst — React client on Web Client Hosting, Serverless Function gateway, and the ML engine on AppSail.</a:t>
+            </a:r>
+          </a:p>
+          <a:p>
+            <a:pPr algn="l">
+              <a:lnSpc>
+                <a:spcPct val="122000"/>
+              </a:lnSpc>
+              <a:spcAft>
+                <a:spcPts val="500"/>
+              </a:spcAft>
+            </a:pPr>
+            <a:r>
+              <a:rPr sz="1300" b="1">
+                <a:solidFill>
+                  <a:srgbClr val="A8231B"/>
+                </a:solidFill>
+                <a:latin typeface="Arial"/>
+              </a:rPr>
+              <a:t>What is in each</a:t>
+            </a:r>
+          </a:p>
+          <a:p>
+            <a:pPr algn="l">
+              <a:lnSpc>
+                <a:spcPct val="122000"/>
+              </a:lnSpc>
+              <a:spcAft>
+                <a:spcPts val="400"/>
+              </a:spcAft>
+            </a:pPr>
+            <a:r>
+              <a:rPr sz="1250" b="1">
+                <a:solidFill>
+                  <a:srgbClr val="333840"/>
+                </a:solidFill>
+                <a:latin typeface="Arial"/>
+              </a:rPr>
+              <a:t>Repository</a:t>
+            </a:r>
+            <a:r>
+              <a:rPr sz="1250" b="0">
+                <a:solidFill>
+                  <a:srgbClr val="333840"/>
+                </a:solidFill>
+                <a:latin typeface="Arial"/>
+              </a:rPr>
+              <a:t> — the full linkage engine, forecast, triage and person resolution; the API gateway with its access-control layer; the job and event functions; the React client; and the synthetic data generator with its ground truth, so every figure on slide 12 can be reproduced.</a:t>
+            </a:r>
+          </a:p>
+          <a:p>
+            <a:pPr algn="l">
+              <a:lnSpc>
+                <a:spcPct val="122000"/>
+              </a:lnSpc>
+              <a:spcAft>
+                <a:spcPts val="400"/>
+              </a:spcAft>
+            </a:pPr>
+            <a:r>
+              <a:rPr sz="1250" b="1">
+                <a:solidFill>
+                  <a:srgbClr val="333840"/>
+                </a:solidFill>
+                <a:latin typeface="Arial"/>
+              </a:rPr>
+              <a:t>Deployed link</a:t>
+            </a:r>
+            <a:r>
+              <a:rPr sz="1250" b="0">
+                <a:solidFill>
+                  <a:srgbClr val="333840"/>
+                </a:solidFill>
+                <a:latin typeface="Arial"/>
+              </a:rPr>
+              <a:t> — open it a minute or two before viewing. The engine idles between uses and the status bar reads ENGINE LIVE once it is warm.</a:t>
+            </a:r>
+          </a:p>
+          <a:p>
+            <a:pPr algn="l">
+              <a:lnSpc>
+                <a:spcPct val="122000"/>
+              </a:lnSpc>
+              <a:spcAft>
                 <a:spcPts val="700"/>
               </a:spcAft>
             </a:pPr>
             <a:r>
+              <a:rPr sz="1250" b="1">
+                <a:solidFill>
+                  <a:srgbClr val="333840"/>
+                </a:solidFill>
+                <a:latin typeface="Arial"/>
+              </a:rPr>
+              <a:t>Deep links worth trying</a:t>
+            </a:r>
+            <a:r>
               <a:rPr sz="1250" b="0">
                 <a:solidFill>
-                  <a:srgbClr val="666C77"/>
-                </a:solidFill>
-                <a:latin typeface="Arial"/>
-              </a:rPr>
-              <a:t>Live on Zoho Catalyst — React client on Web Client Hosting, Serverless Function gateway, and the ML engine on AppSail.</a:t>
+                  <a:srgbClr val="333840"/>
+                </a:solidFill>
+                <a:latin typeface="Arial"/>
+              </a:rPr>
+              <a:t> — ?tab=model for measured accuracy, ?group=SER-001 for a linked group with its forecast, and ?role=investigator&amp;district=577 to see the access model restrict the view.</a:t>
             </a:r>
           </a:p>
         </p:txBody>
@@ -6636,8 +6870,8 @@
         </p:nvSpPr>
         <p:spPr>
           <a:xfrm>
-            <a:off x="502920" y="5806440"/>
-            <a:ext cx="11185855" cy="731520"/>
+            <a:off x="502920" y="4316289"/>
+            <a:ext cx="11185855" cy="2194560"/>
           </a:xfrm>
           <a:prstGeom prst="rect">
             <a:avLst/>
@@ -6649,6 +6883,81 @@
             <a:spAutoFit/>
           </a:bodyPr>
           <a:lstStyle/>
+          <a:p>
+            <a:pPr algn="l">
+              <a:lnSpc>
+                <a:spcPct val="122000"/>
+              </a:lnSpc>
+              <a:spcAft>
+                <a:spcPts val="900"/>
+              </a:spcAft>
+            </a:pPr>
+            <a:r>
+              <a:rPr sz="1250" b="0">
+                <a:solidFill>
+                  <a:srgbClr val="666C77"/>
+                </a:solidFill>
+                <a:latin typeface="Arial"/>
+              </a:rPr>
+              <a:t>The same fingerprint runs in both passes — that is what lets a brand-new FIR be judged against groups built from the archive, and why the two lanes are one system rather than two.</a:t>
+            </a:r>
+          </a:p>
+          <a:p>
+            <a:pPr algn="l">
+              <a:lnSpc>
+                <a:spcPct val="122000"/>
+              </a:lnSpc>
+              <a:spcAft>
+                <a:spcPts val="500"/>
+              </a:spcAft>
+            </a:pPr>
+            <a:r>
+              <a:rPr sz="1250" b="1">
+                <a:solidFill>
+                  <a:srgbClr val="333840"/>
+                </a:solidFill>
+                <a:latin typeface="Arial"/>
+              </a:rPr>
+              <a:t>Archive pass</a:t>
+            </a:r>
+            <a:r>
+              <a:rPr sz="1250" b="0">
+                <a:solidFill>
+                  <a:srgbClr val="333840"/>
+                </a:solidFill>
+                <a:latin typeface="Arial"/>
+              </a:rPr>
+              <a:t> — every undetected FIR is fingerprinted on seven weighted signals, scored against every other case, and clustered. Groups are then ranked by cohesion multiplied by actionability, which favours jurisdictional reach, recency and gravity. Runs nightly.</a:t>
+            </a:r>
+          </a:p>
+          <a:p>
+            <a:pPr algn="l">
+              <a:lnSpc>
+                <a:spcPct val="122000"/>
+              </a:lnSpc>
+              <a:spcAft>
+                <a:spcPts val="500"/>
+              </a:spcAft>
+            </a:pPr>
+            <a:r>
+              <a:rPr sz="1250" b="1">
+                <a:solidFill>
+                  <a:srgbClr val="333840"/>
+                </a:solidFill>
+                <a:latin typeface="Arial"/>
+              </a:rPr>
+              <a:t>Live intake</a:t>
+            </a:r>
+            <a:r>
+              <a:rPr sz="1250" b="0">
+                <a:solidFill>
+                  <a:srgbClr val="333840"/>
+                </a:solidFill>
+                <a:latin typeface="Arial"/>
+              </a:rPr>
+              <a:t> — a newly registered FIR is fingerprinted identically and scored against each group, then graded against that group's own internal cohesion rather than a fixed threshold. A tight group demands a high score; a loose one cannot reach it.</a:t>
+            </a:r>
+          </a:p>
           <a:p>
             <a:pPr algn="l">
               <a:lnSpc>
@@ -6659,13 +6968,22 @@
               </a:spcAft>
             </a:pPr>
             <a:r>
-              <a:rPr sz="1200" b="0">
-                <a:solidFill>
-                  <a:srgbClr val="666C77"/>
-                </a:solidFill>
-                <a:latin typeface="Arial"/>
-              </a:rPr>
-              <a:t>The same fingerprint runs in both passes — that is what lets a brand-new FIR be judged against groups built from the archive, and why the two lanes are one system rather than two.</a:t>
+              <a:rPr sz="1250" b="1">
+                <a:solidFill>
+                  <a:srgbClr val="333840"/>
+                </a:solidFill>
+                <a:latin typeface="Arial"/>
+              </a:rPr>
+              <a:t>Nothing is asserted.</a:t>
+            </a:r>
+            <a:r>
+              <a:rPr sz="1250" b="0">
+                <a:solidFill>
+                  <a:srgbClr val="333840"/>
+                </a:solidFill>
+                <a:latin typeface="Arial"/>
+              </a:rPr>
+              <a:t> Each group carries the per-signal contributions that produced it and the real FIR numbers it cites, so an investigator can audit the reasoning rather than trust the output.</a:t>
             </a:r>
           </a:p>
         </p:txBody>
@@ -6771,16 +7089,40 @@
           </a:p>
         </p:txBody>
       </p:sp>
-      <p:sp>
-        <p:nvSpPr>
-          <p:cNvPr id="5" name="TextBox 4"/>
+      <p:pic>
+        <p:nvPicPr>
+          <p:cNvPr id="5" name="Picture 4" descr="dg_wire.png"/>
+          <p:cNvPicPr>
+            <a:picLocks noChangeAspect="1"/>
+          </p:cNvPicPr>
+          <p:nvPr/>
+        </p:nvPicPr>
+        <p:blipFill>
+          <a:blip r:embed="rId4"/>
+          <a:stretch>
+            <a:fillRect/>
+          </a:stretch>
+        </p:blipFill>
+        <p:spPr>
+          <a:xfrm>
+            <a:off x="960120" y="1490793"/>
+            <a:ext cx="10241280" cy="4471545"/>
+          </a:xfrm>
+          <a:prstGeom prst="rect">
+            <a:avLst/>
+          </a:prstGeom>
+        </p:spPr>
+      </p:pic>
+      <p:sp>
+        <p:nvSpPr>
+          <p:cNvPr id="6" name="TextBox 5"/>
           <p:cNvSpPr txBox="1"/>
           <p:nvPr/>
         </p:nvSpPr>
         <p:spPr>
           <a:xfrm>
-            <a:off x="502920" y="1573089"/>
-            <a:ext cx="11185855" cy="4873430"/>
+            <a:off x="502920" y="6144768"/>
+            <a:ext cx="11185855" cy="548640"/>
           </a:xfrm>
           <a:prstGeom prst="rect">
             <a:avLst/>
@@ -6792,43 +7134,6 @@
             <a:spAutoFit/>
           </a:bodyPr>
           <a:lstStyle/>
-          <a:p>
-            <a:pPr algn="l">
-              <a:lnSpc>
-                <a:spcPct val="122000"/>
-              </a:lnSpc>
-              <a:spcAft>
-                <a:spcPts val="1000"/>
-              </a:spcAft>
-            </a:pPr>
-            <a:r>
-              <a:rPr sz="1500" b="0">
-                <a:solidFill>
-                  <a:srgbClr val="111111"/>
-                </a:solidFill>
-                <a:latin typeface="Arial"/>
-              </a:rPr>
-              <a:t>Not applicable — the prototype is </a:t>
-            </a:r>
-            <a:r>
-              <a:rPr sz="1500" b="1">
-                <a:solidFill>
-                  <a:srgbClr val="111111"/>
-                </a:solidFill>
-                <a:latin typeface="Arial"/>
-              </a:rPr>
-              <a:t>built and deployed</a:t>
-            </a:r>
-            <a:r>
-              <a:rPr sz="1500" b="0">
-                <a:solidFill>
-                  <a:srgbClr val="111111"/>
-                </a:solidFill>
-                <a:latin typeface="Arial"/>
-              </a:rPr>
-              <a:t>, so live screens replace mockups.</a:t>
-            </a:r>
-          </a:p>
           <a:p>
             <a:pPr algn="l">
               <a:lnSpc>
@@ -6839,13 +7144,13 @@
               </a:spcAft>
             </a:pPr>
             <a:r>
-              <a:rPr sz="1350" b="0">
-                <a:solidFill>
-                  <a:srgbClr val="333840"/>
-                </a:solidFill>
-                <a:latin typeface="Arial"/>
-              </a:rPr>
-              <a:t>See slide 11 for snapshots of the working prototype, and the deployed link on slide 13.</a:t>
+              <a:rPr sz="1200" b="0">
+                <a:solidFill>
+                  <a:srgbClr val="666C77"/>
+                </a:solidFill>
+                <a:latin typeface="Arial"/>
+              </a:rPr>
+              <a:t>Three regions, each doing one job: navigation on the rail, the map as the workspace, and the dossier where a lead opens into a full case file with its evidence. Live screens of this layout follow on the next slides.</a:t>
             </a:r>
           </a:p>
         </p:txBody>
@@ -7546,8 +7851,8 @@
         </p:nvSpPr>
         <p:spPr>
           <a:xfrm>
-            <a:off x="502920" y="3996249"/>
-            <a:ext cx="11185855" cy="914400"/>
+            <a:off x="502920" y="3767649"/>
+            <a:ext cx="11185855" cy="2651760"/>
           </a:xfrm>
           <a:prstGeom prst="rect">
             <a:avLst/>
@@ -7559,6 +7864,146 @@
             <a:spAutoFit/>
           </a:bodyPr>
           <a:lstStyle/>
+          <a:p>
+            <a:pPr algn="l">
+              <a:lnSpc>
+                <a:spcPct val="122000"/>
+              </a:lnSpc>
+              <a:spcAft>
+                <a:spcPts val="500"/>
+              </a:spcAft>
+            </a:pPr>
+            <a:r>
+              <a:rPr sz="1300" b="1">
+                <a:solidFill>
+                  <a:srgbClr val="A8231B"/>
+                </a:solidFill>
+                <a:latin typeface="Arial"/>
+              </a:rPr>
+              <a:t>Techniques</a:t>
+            </a:r>
+          </a:p>
+          <a:p>
+            <a:pPr algn="l">
+              <a:lnSpc>
+                <a:spcPct val="122000"/>
+              </a:lnSpc>
+              <a:spcAft>
+                <a:spcPts val="900"/>
+              </a:spcAft>
+            </a:pPr>
+            <a:r>
+              <a:rPr sz="1250" b="0">
+                <a:solidFill>
+                  <a:srgbClr val="333840"/>
+                </a:solidFill>
+                <a:latin typeface="Arial"/>
+              </a:rPr>
+              <a:t>Behavioural fingerprinting · TF-IDF over complaint text · weighted composite similarity with per-pair weight renormalisation · agglomerative clustering on a precomputed distance matrix · leave-one-signal-out ablation · hold-one-out forecast back-testing · Douglas-Peucker simplification for the district meshes.</a:t>
+            </a:r>
+          </a:p>
+          <a:p>
+            <a:pPr algn="l">
+              <a:lnSpc>
+                <a:spcPct val="122000"/>
+              </a:lnSpc>
+              <a:spcAft>
+                <a:spcPts val="500"/>
+              </a:spcAft>
+            </a:pPr>
+            <a:r>
+              <a:rPr sz="1300" b="1">
+                <a:solidFill>
+                  <a:srgbClr val="A8231B"/>
+                </a:solidFill>
+                <a:latin typeface="Arial"/>
+              </a:rPr>
+              <a:t>Design constraints we held to</a:t>
+            </a:r>
+          </a:p>
+          <a:p>
+            <a:pPr algn="l">
+              <a:lnSpc>
+                <a:spcPct val="122000"/>
+              </a:lnSpc>
+              <a:spcAft>
+                <a:spcPts val="400"/>
+              </a:spcAft>
+            </a:pPr>
+            <a:r>
+              <a:rPr sz="1250" b="0">
+                <a:solidFill>
+                  <a:srgbClr val="333840"/>
+                </a:solidFill>
+                <a:latin typeface="Arial"/>
+              </a:rPr>
+              <a:t>• Clustering stays on </a:t>
+            </a:r>
+            <a:r>
+              <a:rPr sz="1250" b="1">
+                <a:solidFill>
+                  <a:srgbClr val="333840"/>
+                </a:solidFill>
+                <a:latin typeface="Arial"/>
+              </a:rPr>
+              <a:t>scikit-learn primitives</a:t>
+            </a:r>
+            <a:r>
+              <a:rPr sz="1250" b="0">
+                <a:solidFill>
+                  <a:srgbClr val="333840"/>
+                </a:solidFill>
+                <a:latin typeface="Arial"/>
+              </a:rPr>
+              <a:t> on purpose, so the whole engine installs from requirements.txt on the Catalyst managed runtime with </a:t>
+            </a:r>
+            <a:r>
+              <a:rPr sz="1250" b="1">
+                <a:solidFill>
+                  <a:srgbClr val="333840"/>
+                </a:solidFill>
+                <a:latin typeface="Arial"/>
+              </a:rPr>
+              <a:t>no native compilation</a:t>
+            </a:r>
+            <a:r>
+              <a:rPr sz="1250" b="0">
+                <a:solidFill>
+                  <a:srgbClr val="333840"/>
+                </a:solidFill>
+                <a:latin typeface="Arial"/>
+              </a:rPr>
+              <a:t>.</a:t>
+            </a:r>
+          </a:p>
+          <a:p>
+            <a:pPr algn="l">
+              <a:lnSpc>
+                <a:spcPct val="122000"/>
+              </a:lnSpc>
+              <a:spcAft>
+                <a:spcPts val="400"/>
+              </a:spcAft>
+            </a:pPr>
+            <a:r>
+              <a:rPr sz="1250" b="1">
+                <a:solidFill>
+                  <a:srgbClr val="333840"/>
+                </a:solidFill>
+                <a:latin typeface="Arial"/>
+              </a:rPr>
+              <a:t>No external LLM API.</a:t>
+            </a:r>
+            <a:r>
+              <a:rPr sz="1250" b="0">
+                <a:solidFill>
+                  <a:srgbClr val="333840"/>
+                </a:solidFill>
+                <a:latin typeface="Arial"/>
+              </a:rPr>
+              <a:t> Retrieval is deterministic, so no case data leaves the Catalyst environment and there is no per-query cost.</a:t>
+            </a:r>
+          </a:p>
           <a:p>
             <a:pPr algn="l">
               <a:lnSpc>
@@ -7569,31 +8014,22 @@
               </a:spcAft>
             </a:pPr>
             <a:r>
+              <a:rPr sz="1250" b="1">
+                <a:solidFill>
+                  <a:srgbClr val="333840"/>
+                </a:solidFill>
+                <a:latin typeface="Arial"/>
+              </a:rPr>
+              <a:t>CPU only</a:t>
+            </a:r>
+            <a:r>
               <a:rPr sz="1250" b="0">
                 <a:solidFill>
-                  <a:srgbClr val="666C77"/>
-                </a:solidFill>
-                <a:latin typeface="Arial"/>
-              </a:rPr>
-              <a:t>Clustering stays on </a:t>
-            </a:r>
-            <a:r>
-              <a:rPr sz="1250" b="1">
-                <a:solidFill>
-                  <a:srgbClr val="666C77"/>
-                </a:solidFill>
-                <a:latin typeface="Arial"/>
-              </a:rPr>
-              <a:t>scikit-learn primitives</a:t>
-            </a:r>
-            <a:r>
-              <a:rPr sz="1250" b="0">
-                <a:solidFill>
-                  <a:srgbClr val="666C77"/>
-                </a:solidFill>
-                <a:latin typeface="Arial"/>
-              </a:rPr>
-              <a:t> on purpose, so the whole engine installs from requirements.txt on the Catalyst managed runtime with no native compilation.</a:t>
+                  <a:srgbClr val="333840"/>
+                </a:solidFill>
+                <a:latin typeface="Arial"/>
+              </a:rPr>
+              <a:t> — no GPU anywhere in the pipeline.</a:t>
             </a:r>
           </a:p>
         </p:txBody>

</xml_diff>

<commit_message>
Rebuild the submission deck for the current prototype
Adds the robustness evidence (negative control, graceful degradation), the Forecast
tab, the association network and the person crime-history trail. Performance now
needs two slides rather than one. Screenshots recaptured against the current UI, and
the wireframe redrawn to include the Forecast tab it was missing.

Co-Authored-By: Claude Opus 5 <noreply@anthropic.com>
</commit_message>
<xml_diff>
--- a/docs/submission/Drishti_KSP_Datathon_2026_Prototype_Submission.pptx
+++ b/docs/submission/Drishti_KSP_Datathon_2026_Prototype_Submission.pptx
@@ -21,6 +21,8 @@
     <p:sldId id="269" r:id="rId20"/>
     <p:sldId id="270" r:id="rId21"/>
     <p:sldId id="271" r:id="rId22"/>
+    <p:sldId id="272" r:id="rId23"/>
+    <p:sldId id="273" r:id="rId24"/>
   </p:sldIdLst>
   <p:sldSz cx="12191695" cy="6858000" type="screen4x3"/>
   <p:notesSz cx="6858000" cy="9144000"/>
@@ -3532,25 +3534,7 @@
                 </a:solidFill>
                 <a:latin typeface="Arial"/>
               </a:rPr>
-              <a:t> — runs on the Catalyst Developer Tier at roughly </a:t>
-            </a:r>
-            <a:r>
-              <a:rPr sz="1300" b="1">
-                <a:solidFill>
-                  <a:srgbClr val="333840"/>
-                </a:solidFill>
-                <a:latin typeface="Arial"/>
-              </a:rPr>
-              <a:t>₹0</a:t>
-            </a:r>
-            <a:r>
-              <a:rPr sz="1300" b="0">
-                <a:solidFill>
-                  <a:srgbClr val="333840"/>
-                </a:solidFill>
-                <a:latin typeface="Arial"/>
-              </a:rPr>
-              <a:t>, within the free tier.</a:t>
+              <a:t> — runs on the Catalyst Developer Tier at roughly ₹0, within the free tier.</a:t>
             </a:r>
           </a:p>
           <a:p>
@@ -3782,7 +3766,7 @@
                 </a:solidFill>
                 <a:latin typeface="Arial"/>
               </a:rPr>
-              <a:t> — every component is either open-source or a Catalyst service already in the KSP stack.</a:t>
+              <a:t> — every component is open-source or a Catalyst service already in the KSP stack.</a:t>
             </a:r>
           </a:p>
           <a:p>
@@ -3948,7 +3932,7 @@
         </p:nvSpPr>
         <p:spPr>
           <a:xfrm>
-            <a:off x="502920" y="4983801"/>
+            <a:off x="502920" y="5148393"/>
             <a:ext cx="5486400" cy="457200"/>
           </a:xfrm>
           <a:prstGeom prst="rect">
@@ -3970,7 +3954,7 @@
                 </a:solidFill>
                 <a:latin typeface="Arial"/>
               </a:rPr>
-              <a:t>Statewide — 789 undetected cases, 16 linked groups</a:t>
+              <a:t>Statewide — 789 undetected cases, 16 linked groups, all cross-station</a:t>
             </a:r>
           </a:p>
         </p:txBody>
@@ -4007,7 +3991,7 @@
         </p:nvSpPr>
         <p:spPr>
           <a:xfrm>
-            <a:off x="6217920" y="4983801"/>
+            <a:off x="6217920" y="5148393"/>
             <a:ext cx="5486400" cy="457200"/>
           </a:xfrm>
           <a:prstGeom prst="rect">
@@ -4029,7 +4013,7 @@
                 </a:solidFill>
                 <a:latin typeface="Arial"/>
               </a:rPr>
-              <a:t>A linked group — evidence trail and next-strike projection</a:t>
+              <a:t>A linked group — evidence trail and the projection written in plain words</a:t>
             </a:r>
           </a:p>
         </p:txBody>
@@ -4167,7 +4151,7 @@
         </p:nvSpPr>
         <p:spPr>
           <a:xfrm>
-            <a:off x="502920" y="4983801"/>
+            <a:off x="502920" y="5148393"/>
             <a:ext cx="5486400" cy="457200"/>
           </a:xfrm>
           <a:prstGeom prst="rect">
@@ -4189,14 +4173,14 @@
                 </a:solidFill>
                 <a:latin typeface="Arial"/>
               </a:rPr>
-              <a:t>Measured accuracy, ablation and the identity experiment</a:t>
+              <a:t>Forecast — all 16 projections ranked, open windows first</a:t>
             </a:r>
           </a:p>
         </p:txBody>
       </p:sp>
       <p:pic>
         <p:nvPicPr>
-          <p:cNvPr id="7" name="Picture 6" descr="shot4.png"/>
+          <p:cNvPr id="7" name="Picture 6" descr="shot6.png"/>
           <p:cNvPicPr>
             <a:picLocks noChangeAspect="1"/>
           </p:cNvPicPr>
@@ -4226,7 +4210,7 @@
         </p:nvSpPr>
         <p:spPr>
           <a:xfrm>
-            <a:off x="6217920" y="4983801"/>
+            <a:off x="6217920" y="5148393"/>
             <a:ext cx="5486400" cy="457200"/>
           </a:xfrm>
           <a:prstGeom prst="rect">
@@ -4248,7 +4232,7 @@
                 </a:solidFill>
                 <a:latin typeface="Arial"/>
               </a:rPr>
-              <a:t>Role-based access — an investigator sees one district</a:t>
+              <a:t>One person's whole crime history drawn on the map in date order</a:t>
             </a:r>
           </a:p>
         </p:txBody>
@@ -4349,21 +4333,45 @@
                 </a:solidFill>
                 <a:latin typeface="Arial"/>
               </a:rPr>
-              <a:t>Prototype Performance report / Benchmarking</a:t>
-            </a:r>
-          </a:p>
-        </p:txBody>
-      </p:sp>
-      <p:sp>
-        <p:nvSpPr>
-          <p:cNvPr id="5" name="TextBox 4"/>
+              <a:t>Snapshots of the prototype</a:t>
+            </a:r>
+          </a:p>
+        </p:txBody>
+      </p:sp>
+      <p:pic>
+        <p:nvPicPr>
+          <p:cNvPr id="5" name="Picture 4" descr="shot4.png"/>
+          <p:cNvPicPr>
+            <a:picLocks noChangeAspect="1"/>
+          </p:cNvPicPr>
+          <p:nvPr/>
+        </p:nvPicPr>
+        <p:blipFill>
+          <a:blip r:embed="rId4"/>
+          <a:stretch>
+            <a:fillRect/>
+          </a:stretch>
+        </p:blipFill>
+        <p:spPr>
+          <a:xfrm>
+            <a:off x="502920" y="1618809"/>
+            <a:ext cx="5486400" cy="3429000"/>
+          </a:xfrm>
+          <a:prstGeom prst="rect">
+            <a:avLst/>
+          </a:prstGeom>
+        </p:spPr>
+      </p:pic>
+      <p:sp>
+        <p:nvSpPr>
+          <p:cNvPr id="6" name="TextBox 5"/>
           <p:cNvSpPr txBox="1"/>
           <p:nvPr/>
         </p:nvSpPr>
         <p:spPr>
           <a:xfrm>
-            <a:off x="502920" y="1573089"/>
-            <a:ext cx="11185855" cy="4873430"/>
+            <a:off x="502920" y="5148393"/>
+            <a:ext cx="5486400" cy="457200"/>
           </a:xfrm>
           <a:prstGeom prst="rect">
             <a:avLst/>
@@ -4376,301 +4384,74 @@
           </a:bodyPr>
           <a:lstStyle/>
           <a:p>
-            <a:pPr algn="l">
-              <a:lnSpc>
-                <a:spcPct val="122000"/>
-              </a:lnSpc>
-              <a:spcAft>
-                <a:spcPts val="500"/>
-              </a:spcAft>
-            </a:pPr>
-            <a:r>
-              <a:rPr sz="1300" b="1">
-                <a:solidFill>
-                  <a:srgbClr val="A8231B"/>
-                </a:solidFill>
-                <a:latin typeface="Arial"/>
-              </a:rPr>
-              <a:t>Linkage accuracy — measured pairwise over every pair of undetected cases against planted ground truth</a:t>
-            </a:r>
-          </a:p>
-          <a:p>
-            <a:pPr algn="l">
-              <a:lnSpc>
-                <a:spcPct val="122000"/>
-              </a:lnSpc>
-              <a:spcAft>
-                <a:spcPts val="1000"/>
-              </a:spcAft>
-            </a:pPr>
-            <a:r>
-              <a:rPr sz="1300" b="1">
-                <a:solidFill>
-                  <a:srgbClr val="111111"/>
-                </a:solidFill>
-                <a:latin typeface="Arial"/>
-              </a:rPr>
-              <a:t>Precision 0.928   ·   Recall 0.965   ·   F1 0.946   ·   13 of 13 planted groups recovered.</a:t>
-            </a:r>
-            <a:r>
-              <a:rPr sz="1300" b="0">
-                <a:solidFill>
-                  <a:srgbClr val="111111"/>
-                </a:solidFill>
-                <a:latin typeface="Arial"/>
-              </a:rPr>
-              <a:t>  Reproducible offline in one command: python appsail-python/run_local.py</a:t>
-            </a:r>
-          </a:p>
-          <a:p>
-            <a:pPr algn="l">
-              <a:lnSpc>
-                <a:spcPct val="122000"/>
-              </a:lnSpc>
-              <a:spcAft>
-                <a:spcPts val="500"/>
-              </a:spcAft>
-            </a:pPr>
-            <a:r>
-              <a:rPr sz="1300" b="1">
-                <a:solidFill>
-                  <a:srgbClr val="A8231B"/>
-                </a:solidFill>
-                <a:latin typeface="Arial"/>
-              </a:rPr>
-              <a:t>What each signal is worth (leave-one-out ablation)</a:t>
-            </a:r>
-          </a:p>
-          <a:p>
-            <a:pPr algn="l">
-              <a:lnSpc>
-                <a:spcPct val="122000"/>
-              </a:lnSpc>
-              <a:spcAft>
-                <a:spcPts val="1000"/>
-              </a:spcAft>
-            </a:pPr>
-            <a:r>
-              <a:rPr sz="1300" b="0">
-                <a:solidFill>
-                  <a:srgbClr val="333840"/>
-                </a:solidFill>
-                <a:latin typeface="Arial"/>
-              </a:rPr>
-              <a:t>Location removed → F1 falls 0.946 to </a:t>
-            </a:r>
-            <a:r>
-              <a:rPr sz="1300" b="1">
-                <a:solidFill>
-                  <a:srgbClr val="333840"/>
-                </a:solidFill>
-                <a:latin typeface="Arial"/>
-              </a:rPr>
-              <a:t>0.363</a:t>
-            </a:r>
-            <a:r>
-              <a:rPr sz="1300" b="0">
-                <a:solidFill>
-                  <a:srgbClr val="333840"/>
-                </a:solidFill>
-                <a:latin typeface="Arial"/>
-              </a:rPr>
-              <a:t>.   Method (MO text) removed → </a:t>
-            </a:r>
-            <a:r>
-              <a:rPr sz="1300" b="1">
-                <a:solidFill>
-                  <a:srgbClr val="333840"/>
-                </a:solidFill>
-                <a:latin typeface="Arial"/>
-              </a:rPr>
-              <a:t>0.438</a:t>
-            </a:r>
-            <a:r>
-              <a:rPr sz="1300" b="0">
-                <a:solidFill>
-                  <a:srgbClr val="333840"/>
-                </a:solidFill>
-                <a:latin typeface="Arial"/>
-              </a:rPr>
-              <a:t>.   Crime type removed → </a:t>
-            </a:r>
-            <a:r>
-              <a:rPr sz="1300" b="1">
-                <a:solidFill>
-                  <a:srgbClr val="333840"/>
-                </a:solidFill>
-                <a:latin typeface="Arial"/>
-              </a:rPr>
-              <a:t>0.737</a:t>
-            </a:r>
-            <a:r>
-              <a:rPr sz="1300" b="0">
-                <a:solidFill>
-                  <a:srgbClr val="333840"/>
-                </a:solidFill>
-                <a:latin typeface="Arial"/>
-              </a:rPr>
-              <a:t>.</a:t>
-            </a:r>
-          </a:p>
-          <a:p>
-            <a:pPr algn="l">
-              <a:lnSpc>
-                <a:spcPct val="122000"/>
-              </a:lnSpc>
-              <a:spcAft>
-                <a:spcPts val="500"/>
-              </a:spcAft>
-            </a:pPr>
-            <a:r>
-              <a:rPr sz="1300" b="1">
-                <a:solidFill>
-                  <a:srgbClr val="A8231B"/>
-                </a:solidFill>
-                <a:latin typeface="Arial"/>
-              </a:rPr>
-              <a:t>The identity experiment</a:t>
-            </a:r>
-          </a:p>
-          <a:p>
-            <a:pPr algn="l">
-              <a:lnSpc>
-                <a:spcPct val="122000"/>
-              </a:lnSpc>
-              <a:spcAft>
-                <a:spcPts val="1000"/>
-              </a:spcAft>
-            </a:pPr>
-            <a:r>
-              <a:rPr sz="1300" b="0">
-                <a:solidFill>
-                  <a:srgbClr val="333840"/>
-                </a:solidFill>
-                <a:latin typeface="Arial"/>
-              </a:rPr>
-              <a:t>Accused name at 8% weight → P 0.919 / R 0.854 / F1 0.885.   </a:t>
-            </a:r>
-            <a:r>
-              <a:rPr sz="1300" b="1">
-                <a:solidFill>
-                  <a:srgbClr val="333840"/>
-                </a:solidFill>
-                <a:latin typeface="Arial"/>
-              </a:rPr>
-              <a:t>At zero weight (shipped) → P 0.928 / R 0.965 / F1 0.946.</a:t>
-            </a:r>
-            <a:r>
-              <a:rPr sz="1300" b="0">
-                <a:solidFill>
-                  <a:srgbClr val="333840"/>
-                </a:solidFill>
-                <a:latin typeface="Arial"/>
-              </a:rPr>
-              <a:t>  Coincidental name collisions pulled unrelated cases into real groups, so identity now carries no weight in linkage at all.</a:t>
-            </a:r>
-          </a:p>
-          <a:p>
-            <a:pPr algn="l">
-              <a:lnSpc>
-                <a:spcPct val="122000"/>
-              </a:lnSpc>
-              <a:spcAft>
-                <a:spcPts val="500"/>
-              </a:spcAft>
-            </a:pPr>
-            <a:r>
-              <a:rPr sz="1300" b="1">
-                <a:solidFill>
-                  <a:srgbClr val="A8231B"/>
-                </a:solidFill>
-                <a:latin typeface="Arial"/>
-              </a:rPr>
-              <a:t>Forecast, back-tested</a:t>
-            </a:r>
-          </a:p>
-          <a:p>
-            <a:pPr algn="l">
-              <a:lnSpc>
-                <a:spcPct val="122000"/>
-              </a:lnSpc>
-              <a:spcAft>
-                <a:spcPts val="1000"/>
-              </a:spcAft>
-            </a:pPr>
-            <a:r>
-              <a:rPr sz="1300" b="0">
-                <a:solidFill>
-                  <a:srgbClr val="333840"/>
-                </a:solidFill>
-                <a:latin typeface="Arial"/>
-              </a:rPr>
-              <a:t>Each group's last offence held out, a projection built from the earlier events only, then checked against what actually happened: </a:t>
-            </a:r>
-            <a:r>
-              <a:rPr sz="1300" b="1">
-                <a:solidFill>
-                  <a:srgbClr val="333840"/>
-                </a:solidFill>
-                <a:latin typeface="Arial"/>
-              </a:rPr>
-              <a:t>area hit rate 92.9%</a:t>
-            </a:r>
-            <a:r>
-              <a:rPr sz="1300" b="0">
-                <a:solidFill>
-                  <a:srgbClr val="333840"/>
-                </a:solidFill>
-                <a:latin typeface="Arial"/>
-              </a:rPr>
-              <a:t>, window hit rate 50.0%, median timing error 7.7 days, across 14 groups. The area holds up far better than the timing — which is why the map ring is the actionable part of the forecast, not the date.</a:t>
-            </a:r>
-          </a:p>
-          <a:p>
-            <a:pPr algn="l">
-              <a:lnSpc>
-                <a:spcPct val="122000"/>
-              </a:lnSpc>
-              <a:spcAft>
-                <a:spcPts val="500"/>
-              </a:spcAft>
-            </a:pPr>
-            <a:r>
-              <a:rPr sz="1300" b="1">
-                <a:solidFill>
-                  <a:srgbClr val="A8231B"/>
-                </a:solidFill>
-                <a:latin typeface="Arial"/>
-              </a:rPr>
-              <a:t>Schema conformance</a:t>
-            </a:r>
-          </a:p>
-          <a:p>
-            <a:pPr algn="l">
-              <a:lnSpc>
-                <a:spcPct val="122000"/>
-              </a:lnSpc>
-              <a:spcAft>
-                <a:spcPts val="700"/>
-              </a:spcAft>
-            </a:pPr>
-            <a:r>
-              <a:rPr sz="1300" b="1">
-                <a:solidFill>
-                  <a:srgbClr val="333840"/>
-                </a:solidFill>
-                <a:latin typeface="Arial"/>
-              </a:rPr>
-              <a:t>28 of 28 ER tables implemented, 42 of 42 foreign keys resolve.</a:t>
-            </a:r>
-            <a:r>
-              <a:rPr sz="1300" b="0">
-                <a:solidFill>
-                  <a:srgbClr val="333840"/>
-                </a:solidFill>
-                <a:latin typeface="Arial"/>
-              </a:rPr>
-              <a:t>  The KSP dataset was not released, so these figures are measured on schema-faithful synthetic data with planted offender groups. Real FIR data swaps in through the same tables and pipeline unchanged, and the accuracy panel re-measures itself against it.</a:t>
+            <a:pPr algn="l"/>
+            <a:r>
+              <a:rPr sz="1150">
+                <a:solidFill>
+                  <a:srgbClr val="666C77"/>
+                </a:solidFill>
+                <a:latin typeface="Arial"/>
+              </a:rPr>
+              <a:t>Association network — 25 people linked by shared modus operandi</a:t>
+            </a:r>
+          </a:p>
+        </p:txBody>
+      </p:sp>
+      <p:pic>
+        <p:nvPicPr>
+          <p:cNvPr id="7" name="Picture 6" descr="shot5.png"/>
+          <p:cNvPicPr>
+            <a:picLocks noChangeAspect="1"/>
+          </p:cNvPicPr>
+          <p:nvPr/>
+        </p:nvPicPr>
+        <p:blipFill>
+          <a:blip r:embed="rId5"/>
+          <a:stretch>
+            <a:fillRect/>
+          </a:stretch>
+        </p:blipFill>
+        <p:spPr>
+          <a:xfrm>
+            <a:off x="6217920" y="1618809"/>
+            <a:ext cx="5486400" cy="3429000"/>
+          </a:xfrm>
+          <a:prstGeom prst="rect">
+            <a:avLst/>
+          </a:prstGeom>
+        </p:spPr>
+      </p:pic>
+      <p:sp>
+        <p:nvSpPr>
+          <p:cNvPr id="8" name="TextBox 7"/>
+          <p:cNvSpPr txBox="1"/>
+          <p:nvPr/>
+        </p:nvSpPr>
+        <p:spPr>
+          <a:xfrm>
+            <a:off x="6217920" y="5148393"/>
+            <a:ext cx="5486400" cy="457200"/>
+          </a:xfrm>
+          <a:prstGeom prst="rect">
+            <a:avLst/>
+          </a:prstGeom>
+          <a:noFill/>
+        </p:spPr>
+        <p:txBody>
+          <a:bodyPr wrap="square">
+            <a:spAutoFit/>
+          </a:bodyPr>
+          <a:lstStyle/>
+          <a:p>
+            <a:pPr algn="l"/>
+            <a:r>
+              <a:rPr sz="1150">
+                <a:solidFill>
+                  <a:srgbClr val="666C77"/>
+                </a:solidFill>
+                <a:latin typeface="Arial"/>
+              </a:rPr>
+              <a:t>Measured accuracy, ablation, and the robustness checks</a:t>
             </a:r>
           </a:p>
         </p:txBody>
@@ -4771,7 +4552,7 @@
                 </a:solidFill>
                 <a:latin typeface="Arial"/>
               </a:rPr>
-              <a:t>Provide links to your:</a:t>
+              <a:t>Prototype Performance report / Benchmarking</a:t>
             </a:r>
           </a:p>
         </p:txBody>
@@ -4797,139 +4578,6 @@
             <a:spAutoFit/>
           </a:bodyPr>
           <a:lstStyle/>
-          <a:p>
-            <a:pPr algn="l">
-              <a:lnSpc>
-                <a:spcPct val="122000"/>
-              </a:lnSpc>
-              <a:spcAft>
-                <a:spcPts val="300"/>
-              </a:spcAft>
-            </a:pPr>
-            <a:r>
-              <a:rPr sz="1500" b="1">
-                <a:solidFill>
-                  <a:srgbClr val="111111"/>
-                </a:solidFill>
-                <a:latin typeface="Arial"/>
-              </a:rPr>
-              <a:t>1.   GitHub Public Repository</a:t>
-            </a:r>
-          </a:p>
-          <a:p>
-            <a:pPr algn="l">
-              <a:lnSpc>
-                <a:spcPct val="122000"/>
-              </a:lnSpc>
-              <a:spcAft>
-                <a:spcPts val="1200"/>
-              </a:spcAft>
-            </a:pPr>
-            <a:r>
-              <a:rPr sz="1400" b="0">
-                <a:solidFill>
-                  <a:srgbClr val="333840"/>
-                </a:solidFill>
-                <a:latin typeface="Arial"/>
-              </a:rPr>
-              <a:t>https://github.com/whysush/drishti-crimelink</a:t>
-            </a:r>
-          </a:p>
-          <a:p>
-            <a:pPr algn="l">
-              <a:lnSpc>
-                <a:spcPct val="122000"/>
-              </a:lnSpc>
-              <a:spcAft>
-                <a:spcPts val="300"/>
-              </a:spcAft>
-            </a:pPr>
-            <a:r>
-              <a:rPr sz="1500" b="1">
-                <a:solidFill>
-                  <a:srgbClr val="111111"/>
-                </a:solidFill>
-                <a:latin typeface="Arial"/>
-              </a:rPr>
-              <a:t>2.   Demo Video Link (3 minutes)</a:t>
-            </a:r>
-          </a:p>
-          <a:p>
-            <a:pPr algn="l">
-              <a:lnSpc>
-                <a:spcPct val="122000"/>
-              </a:lnSpc>
-              <a:spcAft>
-                <a:spcPts val="1200"/>
-              </a:spcAft>
-            </a:pPr>
-            <a:r>
-              <a:rPr sz="1300" b="0">
-                <a:solidFill>
-                  <a:srgbClr val="333840"/>
-                </a:solidFill>
-                <a:latin typeface="Arial"/>
-              </a:rPr>
-              <a:t>https://drive.google.com/file/d/1-NFxiHr9veflHYR7-AuijxACmk5u-CWV/view?usp=sharing</a:t>
-            </a:r>
-          </a:p>
-          <a:p>
-            <a:pPr algn="l">
-              <a:lnSpc>
-                <a:spcPct val="122000"/>
-              </a:lnSpc>
-              <a:spcAft>
-                <a:spcPts val="300"/>
-              </a:spcAft>
-            </a:pPr>
-            <a:r>
-              <a:rPr sz="1500" b="1">
-                <a:solidFill>
-                  <a:srgbClr val="111111"/>
-                </a:solidFill>
-                <a:latin typeface="Arial"/>
-              </a:rPr>
-              <a:t>3.   Deployed Link</a:t>
-            </a:r>
-          </a:p>
-          <a:p>
-            <a:pPr algn="l">
-              <a:lnSpc>
-                <a:spcPct val="122000"/>
-              </a:lnSpc>
-              <a:spcAft>
-                <a:spcPts val="1400"/>
-              </a:spcAft>
-            </a:pPr>
-            <a:r>
-              <a:rPr sz="1400" b="0">
-                <a:solidFill>
-                  <a:srgbClr val="333840"/>
-                </a:solidFill>
-                <a:latin typeface="Arial"/>
-              </a:rPr>
-              <a:t>https://crimelink-927199644.development.catalystserverless.com/app/index.html</a:t>
-            </a:r>
-          </a:p>
-          <a:p>
-            <a:pPr algn="l">
-              <a:lnSpc>
-                <a:spcPct val="122000"/>
-              </a:lnSpc>
-              <a:spcAft>
-                <a:spcPts val="1200"/>
-              </a:spcAft>
-            </a:pPr>
-            <a:r>
-              <a:rPr sz="1250" b="0">
-                <a:solidFill>
-                  <a:srgbClr val="666C77"/>
-                </a:solidFill>
-                <a:latin typeface="Arial"/>
-              </a:rPr>
-              <a:t>Live on Zoho Catalyst — React client on Web Client Hosting, Serverless Function gateway, and the ML engine on AppSail.</a:t>
-            </a:r>
-          </a:p>
           <a:p>
             <a:pPr algn="l">
               <a:lnSpc>
@@ -4946,7 +4594,7 @@
                 </a:solidFill>
                 <a:latin typeface="Arial"/>
               </a:rPr>
-              <a:t>What is in each</a:t>
+              <a:t>Linkage accuracy — pairwise over every pair of undetected cases against planted ground truth</a:t>
             </a:r>
           </a:p>
           <a:p>
@@ -4955,26 +4603,26 @@
                 <a:spcPct val="122000"/>
               </a:lnSpc>
               <a:spcAft>
-                <a:spcPts val="400"/>
+                <a:spcPts val="1300"/>
               </a:spcAft>
             </a:pPr>
             <a:r>
-              <a:rPr sz="1250" b="1">
-                <a:solidFill>
-                  <a:srgbClr val="333840"/>
-                </a:solidFill>
-                <a:latin typeface="Arial"/>
-              </a:rPr>
-              <a:t>Repository</a:t>
-            </a:r>
-            <a:r>
-              <a:rPr sz="1250" b="0">
-                <a:solidFill>
-                  <a:srgbClr val="333840"/>
-                </a:solidFill>
-                <a:latin typeface="Arial"/>
-              </a:rPr>
-              <a:t> — the full linkage engine, forecast, triage and person resolution; the API gateway with its access-control layer; the job and event functions; the React client; and the synthetic data generator with its ground truth, so every figure on slide 12 can be reproduced.</a:t>
+              <a:rPr sz="1300" b="1">
+                <a:solidFill>
+                  <a:srgbClr val="111111"/>
+                </a:solidFill>
+                <a:latin typeface="Arial"/>
+              </a:rPr>
+              <a:t>Precision 0.928   ·   Recall 0.965   ·   F1 0.946   ·   13 of 13 planted groups recovered.</a:t>
+            </a:r>
+            <a:r>
+              <a:rPr sz="1300" b="0">
+                <a:solidFill>
+                  <a:srgbClr val="111111"/>
+                </a:solidFill>
+                <a:latin typeface="Arial"/>
+              </a:rPr>
+              <a:t>   Reproducible offline in one command: python appsail-python/run_local.py</a:t>
             </a:r>
           </a:p>
           <a:p>
@@ -4983,26 +4631,120 @@
                 <a:spcPct val="122000"/>
               </a:lnSpc>
               <a:spcAft>
-                <a:spcPts val="400"/>
+                <a:spcPts val="500"/>
               </a:spcAft>
             </a:pPr>
             <a:r>
-              <a:rPr sz="1250" b="1">
-                <a:solidFill>
-                  <a:srgbClr val="333840"/>
-                </a:solidFill>
-                <a:latin typeface="Arial"/>
-              </a:rPr>
-              <a:t>Deployed link</a:t>
-            </a:r>
-            <a:r>
-              <a:rPr sz="1250" b="0">
-                <a:solidFill>
-                  <a:srgbClr val="333840"/>
-                </a:solidFill>
-                <a:latin typeface="Arial"/>
-              </a:rPr>
-              <a:t> — open it a minute or two before viewing. The engine idles between uses and the status bar reads ENGINE LIVE once it is warm.</a:t>
+              <a:rPr sz="1300" b="1">
+                <a:solidFill>
+                  <a:srgbClr val="A8231B"/>
+                </a:solidFill>
+                <a:latin typeface="Arial"/>
+              </a:rPr>
+              <a:t>Does it invent groups?  —  the negative control</a:t>
+            </a:r>
+          </a:p>
+          <a:p>
+            <a:pPr algn="l">
+              <a:lnSpc>
+                <a:spcPct val="122000"/>
+              </a:lnSpc>
+              <a:spcAft>
+                <a:spcPts val="600"/>
+              </a:spcAft>
+            </a:pPr>
+            <a:r>
+              <a:rPr sz="1300" b="0">
+                <a:solidFill>
+                  <a:srgbClr val="333840"/>
+                </a:solidFill>
+                <a:latin typeface="Arial"/>
+              </a:rPr>
+              <a:t>Every behavioural field is shuffled independently, so all the same texts, times, places and crime types remain in the same proportions and only the link between a case and its own behaviour is destroyed. No offender pattern can survive.</a:t>
+            </a:r>
+          </a:p>
+          <a:p>
+            <a:pPr algn="l">
+              <a:lnSpc>
+                <a:spcPct val="122000"/>
+              </a:lnSpc>
+              <a:spcAft>
+                <a:spcPts val="1300"/>
+              </a:spcAft>
+            </a:pPr>
+            <a:r>
+              <a:rPr sz="1300" b="1">
+                <a:solidFill>
+                  <a:srgbClr val="111111"/>
+                </a:solidFill>
+                <a:latin typeface="Arial"/>
+              </a:rPr>
+              <a:t>16 groups on the real data.   0, 0 and 0 across three scrambled runs.</a:t>
+            </a:r>
+            <a:r>
+              <a:rPr sz="1300" b="0">
+                <a:solidFill>
+                  <a:srgbClr val="111111"/>
+                </a:solidFill>
+                <a:latin typeface="Arial"/>
+              </a:rPr>
+              <a:t>   The engine reports nothing when there is nothing to find — which is what makes the accuracy figures above worth reading.</a:t>
+            </a:r>
+          </a:p>
+          <a:p>
+            <a:pPr algn="l">
+              <a:lnSpc>
+                <a:spcPct val="122000"/>
+              </a:lnSpc>
+              <a:spcAft>
+                <a:spcPts val="500"/>
+              </a:spcAft>
+            </a:pPr>
+            <a:r>
+              <a:rPr sz="1300" b="1">
+                <a:solidFill>
+                  <a:srgbClr val="A8231B"/>
+                </a:solidFill>
+                <a:latin typeface="Arial"/>
+              </a:rPr>
+              <a:t>What happens when the free-text description is missing?</a:t>
+            </a:r>
+          </a:p>
+          <a:p>
+            <a:pPr algn="l">
+              <a:lnSpc>
+                <a:spcPct val="122000"/>
+              </a:lnSpc>
+              <a:spcAft>
+                <a:spcPts val="600"/>
+              </a:spcAft>
+            </a:pPr>
+            <a:r>
+              <a:rPr sz="1300" b="0">
+                <a:solidFill>
+                  <a:srgbClr val="333840"/>
+                </a:solidFill>
+                <a:latin typeface="Arial"/>
+              </a:rPr>
+              <a:t>Full text → </a:t>
+            </a:r>
+            <a:r>
+              <a:rPr sz="1300" b="1">
+                <a:solidFill>
+                  <a:srgbClr val="333840"/>
+                </a:solidFill>
+                <a:latin typeface="Arial"/>
+              </a:rPr>
+              <a:t>16 groups, P 0.928, 13/13 recovered</a:t>
+            </a:r>
+            <a:r>
+              <a:rPr sz="1300" b="0">
+                <a:solidFill>
+                  <a:srgbClr val="333840"/>
+                </a:solidFill>
+                <a:latin typeface="Arial"/>
+              </a:rPr>
+              <a:t>.     50% blank → 15 groups, P 0.778, 10/13.     100% blank → 14 groups, P 0.630, 7/13.</a:t>
             </a:r>
           </a:p>
           <a:p>
@@ -5015,22 +4757,31 @@
               </a:spcAft>
             </a:pPr>
             <a:r>
-              <a:rPr sz="1250" b="1">
-                <a:solidFill>
-                  <a:srgbClr val="333840"/>
-                </a:solidFill>
-                <a:latin typeface="Arial"/>
-              </a:rPr>
-              <a:t>Deep links worth trying</a:t>
-            </a:r>
-            <a:r>
-              <a:rPr sz="1250" b="0">
-                <a:solidFill>
-                  <a:srgbClr val="333840"/>
-                </a:solidFill>
-                <a:latin typeface="Arial"/>
-              </a:rPr>
-              <a:t> — ?tab=model for measured accuracy, ?group=SER-001 for a linked group with its forecast, and ?role=investigator&amp;district=577 to see the access model restrict the view.</a:t>
+              <a:rPr sz="1300" b="0">
+                <a:solidFill>
+                  <a:srgbClr val="333840"/>
+                </a:solidFill>
+                <a:latin typeface="Arial"/>
+              </a:rPr>
+              <a:t>Fewer groups with lower recall is the intended behaviour: on thin evidence the engine should get more cautious, not louder. Without the evidence-coverage discount this returned </a:t>
+            </a:r>
+            <a:r>
+              <a:rPr sz="1300" b="1">
+                <a:solidFill>
+                  <a:srgbClr val="333840"/>
+                </a:solidFill>
+                <a:latin typeface="Arial"/>
+              </a:rPr>
+              <a:t>53 groups at precision 0.375</a:t>
+            </a:r>
+            <a:r>
+              <a:rPr sz="1300" b="0">
+                <a:solidFill>
+                  <a:srgbClr val="333840"/>
+                </a:solidFill>
+                <a:latin typeface="Arial"/>
+              </a:rPr>
+              <a:t> — a flood of false leads.</a:t>
             </a:r>
           </a:p>
         </p:txBody>
@@ -5131,7 +4882,7 @@
                 </a:solidFill>
                 <a:latin typeface="Arial"/>
               </a:rPr>
-              <a:t>Additional Details / Future Development</a:t>
+              <a:t>Performance report / Benchmarking (continued)</a:t>
             </a:r>
           </a:p>
         </p:txBody>
@@ -5157,6 +4908,25 @@
             <a:spAutoFit/>
           </a:bodyPr>
           <a:lstStyle/>
+          <a:p>
+            <a:pPr algn="l">
+              <a:lnSpc>
+                <a:spcPct val="122000"/>
+              </a:lnSpc>
+              <a:spcAft>
+                <a:spcPts val="500"/>
+              </a:spcAft>
+            </a:pPr>
+            <a:r>
+              <a:rPr sz="1300" b="1">
+                <a:solidFill>
+                  <a:srgbClr val="A8231B"/>
+                </a:solidFill>
+                <a:latin typeface="Arial"/>
+              </a:rPr>
+              <a:t>What each signal is worth — leave-one-out ablation</a:t>
+            </a:r>
+          </a:p>
           <a:p>
             <a:pPr algn="l">
               <a:lnSpc>
@@ -5167,13 +4937,41 @@
               </a:spcAft>
             </a:pPr>
             <a:r>
+              <a:rPr sz="1300" b="0">
+                <a:solidFill>
+                  <a:srgbClr val="333840"/>
+                </a:solidFill>
+                <a:latin typeface="Arial"/>
+              </a:rPr>
+              <a:t>Each signal's weight is set to zero and the whole pipeline re-run; the drop in F1 is what that signal is worth.</a:t>
+            </a:r>
+          </a:p>
+          <a:p>
+            <a:pPr algn="l">
+              <a:lnSpc>
+                <a:spcPct val="122000"/>
+              </a:lnSpc>
+              <a:spcAft>
+                <a:spcPts val="1300"/>
+              </a:spcAft>
+            </a:pPr>
+            <a:r>
+              <a:rPr sz="1300" b="0">
+                <a:solidFill>
+                  <a:srgbClr val="333840"/>
+                </a:solidFill>
+                <a:latin typeface="Arial"/>
+              </a:rPr>
+              <a:t>Location removed → F1 falls 0.946 to </a:t>
+            </a:r>
+            <a:r>
               <a:rPr sz="1300" b="1">
                 <a:solidFill>
                   <a:srgbClr val="333840"/>
                 </a:solidFill>
                 <a:latin typeface="Arial"/>
               </a:rPr>
-              <a:t>Go live on real FIR data.</a:t>
+              <a:t>0.363</a:t>
             </a:r>
             <a:r>
               <a:rPr sz="1300" b="0">
@@ -5182,7 +4980,80 @@
                 </a:solidFill>
                 <a:latin typeface="Arial"/>
               </a:rPr>
-              <a:t> The Data Store schema and loader are built and the engine already has a Data Store backend; populating the 28 tables switches the source with no code change. Full-text search on BriefFacts comes with it.</a:t>
+              <a:t>.     Method, the MO text → </a:t>
+            </a:r>
+            <a:r>
+              <a:rPr sz="1300" b="1">
+                <a:solidFill>
+                  <a:srgbClr val="333840"/>
+                </a:solidFill>
+                <a:latin typeface="Arial"/>
+              </a:rPr>
+              <a:t>0.438</a:t>
+            </a:r>
+            <a:r>
+              <a:rPr sz="1300" b="0">
+                <a:solidFill>
+                  <a:srgbClr val="333840"/>
+                </a:solidFill>
+                <a:latin typeface="Arial"/>
+              </a:rPr>
+              <a:t>.     Crime type → </a:t>
+            </a:r>
+            <a:r>
+              <a:rPr sz="1300" b="1">
+                <a:solidFill>
+                  <a:srgbClr val="333840"/>
+                </a:solidFill>
+                <a:latin typeface="Arial"/>
+              </a:rPr>
+              <a:t>0.737</a:t>
+            </a:r>
+            <a:r>
+              <a:rPr sz="1300" b="0">
+                <a:solidFill>
+                  <a:srgbClr val="333840"/>
+                </a:solidFill>
+                <a:latin typeface="Arial"/>
+              </a:rPr>
+              <a:t>.     Who was targeted → </a:t>
+            </a:r>
+            <a:r>
+              <a:rPr sz="1300" b="1">
+                <a:solidFill>
+                  <a:srgbClr val="333840"/>
+                </a:solidFill>
+                <a:latin typeface="Arial"/>
+              </a:rPr>
+              <a:t>0.780</a:t>
+            </a:r>
+            <a:r>
+              <a:rPr sz="1300" b="0">
+                <a:solidFill>
+                  <a:srgbClr val="333840"/>
+                </a:solidFill>
+                <a:latin typeface="Arial"/>
+              </a:rPr>
+              <a:t>.</a:t>
+            </a:r>
+          </a:p>
+          <a:p>
+            <a:pPr algn="l">
+              <a:lnSpc>
+                <a:spcPct val="122000"/>
+              </a:lnSpc>
+              <a:spcAft>
+                <a:spcPts val="500"/>
+              </a:spcAft>
+            </a:pPr>
+            <a:r>
+              <a:rPr sz="1300" b="1">
+                <a:solidFill>
+                  <a:srgbClr val="A8231B"/>
+                </a:solidFill>
+                <a:latin typeface="Arial"/>
+              </a:rPr>
+              <a:t>The identity experiment</a:t>
             </a:r>
           </a:p>
           <a:p>
@@ -5195,22 +5066,22 @@
               </a:spcAft>
             </a:pPr>
             <a:r>
+              <a:rPr sz="1300" b="0">
+                <a:solidFill>
+                  <a:srgbClr val="333840"/>
+                </a:solidFill>
+                <a:latin typeface="Arial"/>
+              </a:rPr>
+              <a:t>Accused name at 8% weight → P 0.916 / R 0.819 / F1 0.865.     </a:t>
+            </a:r>
+            <a:r>
               <a:rPr sz="1300" b="1">
                 <a:solidFill>
                   <a:srgbClr val="333840"/>
                 </a:solidFill>
                 <a:latin typeface="Arial"/>
               </a:rPr>
-              <a:t>Promote to a Production environment.</a:t>
-            </a:r>
-            <a:r>
-              <a:rPr sz="1300" b="0">
-                <a:solidFill>
-                  <a:srgbClr val="333840"/>
-                </a:solidFill>
-                <a:latin typeface="Arial"/>
-              </a:rPr>
-              <a:t> The prototype runs on the Catalyst Development environment.</a:t>
+              <a:t>At zero weight, as shipped → P 0.928 / R 0.965 / F1 0.946.</a:t>
             </a:r>
           </a:p>
           <a:p>
@@ -5219,138 +5090,17 @@
                 <a:spcPct val="122000"/>
               </a:lnSpc>
               <a:spcAft>
-                <a:spcPts val="600"/>
+                <a:spcPts val="1300"/>
               </a:spcAft>
             </a:pPr>
             <a:r>
-              <a:rPr sz="1300" b="1">
-                <a:solidFill>
-                  <a:srgbClr val="333840"/>
-                </a:solidFill>
-                <a:latin typeface="Arial"/>
-              </a:rPr>
-              <a:t>Close the loop on the auto-flag.</a:t>
-            </a:r>
-            <a:r>
               <a:rPr sz="1300" b="0">
                 <a:solidFill>
                   <a:srgbClr val="333840"/>
                 </a:solidFill>
                 <a:latin typeface="Arial"/>
               </a:rPr>
-              <a:t> The Signals event function is deployed; binding it to the FIR insert event turns triage from a screen an officer opens into something that happens the moment a case is registered.</a:t>
-            </a:r>
-          </a:p>
-          <a:p>
-            <a:pPr algn="l">
-              <a:lnSpc>
-                <a:spcPct val="122000"/>
-              </a:lnSpc>
-              <a:spcAft>
-                <a:spcPts val="600"/>
-              </a:spcAft>
-            </a:pPr>
-            <a:r>
-              <a:rPr sz="1300" b="1">
-                <a:solidFill>
-                  <a:srgbClr val="333840"/>
-                </a:solidFill>
-                <a:latin typeface="Arial"/>
-              </a:rPr>
-              <a:t>Kannada voice and translation.</a:t>
-            </a:r>
-            <a:r>
-              <a:rPr sz="1300" b="0">
-                <a:solidFill>
-                  <a:srgbClr val="333840"/>
-                </a:solidFill>
-                <a:latin typeface="Arial"/>
-              </a:rPr>
-              <a:t> The interface is already bilingual; Zia Services would add speech input and translation of free-text complaints.</a:t>
-            </a:r>
-          </a:p>
-          <a:p>
-            <a:pPr algn="l">
-              <a:lnSpc>
-                <a:spcPct val="122000"/>
-              </a:lnSpc>
-              <a:spcAft>
-                <a:spcPts val="600"/>
-              </a:spcAft>
-            </a:pPr>
-            <a:r>
-              <a:rPr sz="1300" b="1">
-                <a:solidFill>
-                  <a:srgbClr val="333840"/>
-                </a:solidFill>
-                <a:latin typeface="Arial"/>
-              </a:rPr>
-              <a:t>QuickML for richer semantic search.</a:t>
-            </a:r>
-            <a:r>
-              <a:rPr sz="1300" b="0">
-                <a:solidFill>
-                  <a:srgbClr val="333840"/>
-                </a:solidFill>
-                <a:latin typeface="Arial"/>
-              </a:rPr>
-              <a:t> Retrieval today is deterministic; a RAG layer over the same cited records would widen natural-language querying without loosening the no-hallucination guarantee.</a:t>
-            </a:r>
-          </a:p>
-          <a:p>
-            <a:pPr algn="l">
-              <a:lnSpc>
-                <a:spcPct val="122000"/>
-              </a:lnSpc>
-              <a:spcAft>
-                <a:spcPts val="600"/>
-              </a:spcAft>
-            </a:pPr>
-            <a:r>
-              <a:rPr sz="1300" b="1">
-                <a:solidFill>
-                  <a:srgbClr val="333840"/>
-                </a:solidFill>
-                <a:latin typeface="Arial"/>
-              </a:rPr>
-              <a:t>Zia AutoML for district-level risk forecasting</a:t>
-            </a:r>
-            <a:r>
-              <a:rPr sz="1300" b="0">
-                <a:solidFill>
-                  <a:srgbClr val="333840"/>
-                </a:solidFill>
-                <a:latin typeface="Arial"/>
-              </a:rPr>
-              <a:t>, complementing the per-group projection already shipped.</a:t>
-            </a:r>
-          </a:p>
-          <a:p>
-            <a:pPr algn="l">
-              <a:lnSpc>
-                <a:spcPct val="122000"/>
-              </a:lnSpc>
-              <a:spcAft>
-                <a:spcPts val="1200"/>
-              </a:spcAft>
-            </a:pPr>
-            <a:r>
-              <a:rPr sz="1300" b="1">
-                <a:solidFill>
-                  <a:srgbClr val="333840"/>
-                </a:solidFill>
-                <a:latin typeface="Arial"/>
-              </a:rPr>
-              <a:t>Learn from investigator feedback.</a:t>
-            </a:r>
-            <a:r>
-              <a:rPr sz="1300" b="0">
-                <a:solidFill>
-                  <a:srgbClr val="333840"/>
-                </a:solidFill>
-                <a:latin typeface="Arial"/>
-              </a:rPr>
-              <a:t> Every group can be marked assigned or dismissed — those judgements are the labels needed to tune signal weights against real outcomes rather than planted ground truth.</a:t>
+              <a:t>Coincidental name collisions pulled unrelated cases into real groups. Identity now carries no weight in linkage at all; a recurring name is shown to the investigator as unconfirmed corroboration only.</a:t>
             </a:r>
           </a:p>
           <a:p>
@@ -5369,7 +5119,63 @@
                 </a:solidFill>
                 <a:latin typeface="Arial"/>
               </a:rPr>
-              <a:t>Where the method fails — stated on the slide deliberately</a:t>
+              <a:t>Forecast, back-tested</a:t>
+            </a:r>
+          </a:p>
+          <a:p>
+            <a:pPr algn="l">
+              <a:lnSpc>
+                <a:spcPct val="122000"/>
+              </a:lnSpc>
+              <a:spcAft>
+                <a:spcPts val="1300"/>
+              </a:spcAft>
+            </a:pPr>
+            <a:r>
+              <a:rPr sz="1300" b="0">
+                <a:solidFill>
+                  <a:srgbClr val="333840"/>
+                </a:solidFill>
+                <a:latin typeface="Arial"/>
+              </a:rPr>
+              <a:t>Each group's last offence was held out and a projection built from the earlier events only, then checked against what actually happened: </a:t>
+            </a:r>
+            <a:r>
+              <a:rPr sz="1300" b="1">
+                <a:solidFill>
+                  <a:srgbClr val="333840"/>
+                </a:solidFill>
+                <a:latin typeface="Arial"/>
+              </a:rPr>
+              <a:t>area hit rate 92.9%</a:t>
+            </a:r>
+            <a:r>
+              <a:rPr sz="1300" b="0">
+                <a:solidFill>
+                  <a:srgbClr val="333840"/>
+                </a:solidFill>
+                <a:latin typeface="Arial"/>
+              </a:rPr>
+              <a:t>, window hit rate 50.0%, median timing error 7.7 days, across 14 groups. The area holds up far better than the timing — which is why the ring on the map is the actionable part of the projection, not the date.</a:t>
+            </a:r>
+          </a:p>
+          <a:p>
+            <a:pPr algn="l">
+              <a:lnSpc>
+                <a:spcPct val="122000"/>
+              </a:lnSpc>
+              <a:spcAft>
+                <a:spcPts val="500"/>
+              </a:spcAft>
+            </a:pPr>
+            <a:r>
+              <a:rPr sz="1300" b="1">
+                <a:solidFill>
+                  <a:srgbClr val="A8231B"/>
+                </a:solidFill>
+                <a:latin typeface="Arial"/>
+              </a:rPr>
+              <a:t>Schema conformance and the data these figures come from</a:t>
             </a:r>
           </a:p>
           <a:p>
@@ -5382,49 +5188,22 @@
               </a:spcAft>
             </a:pPr>
             <a:r>
-              <a:rPr sz="1250" b="0">
-                <a:solidFill>
-                  <a:srgbClr val="333840"/>
-                </a:solidFill>
-                <a:latin typeface="Arial"/>
-              </a:rPr>
-              <a:t>Links are </a:t>
-            </a:r>
-            <a:r>
-              <a:rPr sz="1250" b="1">
-                <a:solidFill>
-                  <a:srgbClr val="333840"/>
-                </a:solidFill>
-                <a:latin typeface="Arial"/>
-              </a:rPr>
-              <a:t>inferred, never asserted</a:t>
-            </a:r>
-            <a:r>
-              <a:rPr sz="1250" b="0">
-                <a:solidFill>
-                  <a:srgbClr val="333840"/>
-                </a:solidFill>
-                <a:latin typeface="Arial"/>
-              </a:rPr>
-              <a:t> — a lead to investigate, not evidence. Two unrelated offenders working the same market at the same hour can look alike. Sparse complaint text weakens the strongest signal, though the weights renormalise so linkage still runs. Complainant caste and religion exist in the schema and are </a:t>
-            </a:r>
-            <a:r>
-              <a:rPr sz="1250" b="1">
-                <a:solidFill>
-                  <a:srgbClr val="333840"/>
-                </a:solidFill>
-                <a:latin typeface="Arial"/>
-              </a:rPr>
-              <a:t>deliberately excluded</a:t>
-            </a:r>
-            <a:r>
-              <a:rPr sz="1250" b="0">
-                <a:solidFill>
-                  <a:srgbClr val="333840"/>
-                </a:solidFill>
-                <a:latin typeface="Arial"/>
-              </a:rPr>
-              <a:t> from linkage.</a:t>
+              <a:rPr sz="1300" b="1">
+                <a:solidFill>
+                  <a:srgbClr val="333840"/>
+                </a:solidFill>
+                <a:latin typeface="Arial"/>
+              </a:rPr>
+              <a:t>28 of 28 ER tables implemented, all foreign keys resolve.</a:t>
+            </a:r>
+            <a:r>
+              <a:rPr sz="1300" b="0">
+                <a:solidFill>
+                  <a:srgbClr val="333840"/>
+                </a:solidFill>
+                <a:latin typeface="Arial"/>
+              </a:rPr>
+              <a:t>   The KSP dataset was not released, so these figures are measured on schema-faithful synthetic data with planted offender groups. Real FIR data swaps in through the same tables and pipeline unchanged, and the accuracy panel re-measures itself against it.</a:t>
             </a:r>
           </a:p>
         </p:txBody>
@@ -5438,6 +5217,685 @@
 </file>
 
 <file path=ppt/slides/slide16.xml><?xml version="1.0" encoding="utf-8"?>
+<p:sld xmlns:a="http://schemas.openxmlformats.org/drawingml/2006/main" xmlns:p="http://schemas.openxmlformats.org/presentationml/2006/main" xmlns:r="http://schemas.openxmlformats.org/officeDocument/2006/relationships">
+  <p:cSld>
+    <p:spTree>
+      <p:nvGrpSpPr>
+        <p:cNvPr id="1" name=""/>
+        <p:cNvGrpSpPr/>
+        <p:nvPr/>
+      </p:nvGrpSpPr>
+      <p:grpSpPr/>
+      <p:pic>
+        <p:nvPicPr>
+          <p:cNvPr id="2" name="Picture 1" descr="header.png"/>
+          <p:cNvPicPr>
+            <a:picLocks noChangeAspect="1"/>
+          </p:cNvPicPr>
+          <p:nvPr/>
+        </p:nvPicPr>
+        <p:blipFill>
+          <a:blip r:embed="rId2"/>
+          <a:stretch>
+            <a:fillRect/>
+          </a:stretch>
+        </p:blipFill>
+        <p:spPr>
+          <a:xfrm>
+            <a:off x="0" y="0"/>
+            <a:ext cx="12191695" cy="704409"/>
+          </a:xfrm>
+          <a:prstGeom prst="rect">
+            <a:avLst/>
+          </a:prstGeom>
+        </p:spPr>
+      </p:pic>
+      <p:pic>
+        <p:nvPicPr>
+          <p:cNvPr id="3" name="Picture 2" descr="footer.png"/>
+          <p:cNvPicPr>
+            <a:picLocks noChangeAspect="1"/>
+          </p:cNvPicPr>
+          <p:nvPr/>
+        </p:nvPicPr>
+        <p:blipFill>
+          <a:blip r:embed="rId3"/>
+          <a:stretch>
+            <a:fillRect/>
+          </a:stretch>
+        </p:blipFill>
+        <p:spPr>
+          <a:xfrm>
+            <a:off x="0" y="6708990"/>
+            <a:ext cx="12191695" cy="149010"/>
+          </a:xfrm>
+          <a:prstGeom prst="rect">
+            <a:avLst/>
+          </a:prstGeom>
+        </p:spPr>
+      </p:pic>
+      <p:sp>
+        <p:nvSpPr>
+          <p:cNvPr id="4" name="TextBox 3"/>
+          <p:cNvSpPr txBox="1"/>
+          <p:nvPr/>
+        </p:nvSpPr>
+        <p:spPr>
+          <a:xfrm>
+            <a:off x="384048" y="905577"/>
+            <a:ext cx="11368735" cy="548640"/>
+          </a:xfrm>
+          <a:prstGeom prst="rect">
+            <a:avLst/>
+          </a:prstGeom>
+          <a:noFill/>
+        </p:spPr>
+        <p:txBody>
+          <a:bodyPr wrap="square">
+            <a:spAutoFit/>
+          </a:bodyPr>
+          <a:lstStyle/>
+          <a:p>
+            <a:pPr algn="l"/>
+            <a:r>
+              <a:rPr sz="2600" b="1">
+                <a:solidFill>
+                  <a:srgbClr val="111111"/>
+                </a:solidFill>
+                <a:latin typeface="Arial"/>
+              </a:rPr>
+              <a:t>Provide links to your:</a:t>
+            </a:r>
+          </a:p>
+        </p:txBody>
+      </p:sp>
+      <p:sp>
+        <p:nvSpPr>
+          <p:cNvPr id="5" name="TextBox 4"/>
+          <p:cNvSpPr txBox="1"/>
+          <p:nvPr/>
+        </p:nvSpPr>
+        <p:spPr>
+          <a:xfrm>
+            <a:off x="502920" y="1573089"/>
+            <a:ext cx="11185855" cy="4873430"/>
+          </a:xfrm>
+          <a:prstGeom prst="rect">
+            <a:avLst/>
+          </a:prstGeom>
+          <a:noFill/>
+        </p:spPr>
+        <p:txBody>
+          <a:bodyPr wrap="square">
+            <a:spAutoFit/>
+          </a:bodyPr>
+          <a:lstStyle/>
+          <a:p>
+            <a:pPr algn="l">
+              <a:lnSpc>
+                <a:spcPct val="122000"/>
+              </a:lnSpc>
+              <a:spcAft>
+                <a:spcPts val="300"/>
+              </a:spcAft>
+            </a:pPr>
+            <a:r>
+              <a:rPr sz="1500" b="1">
+                <a:solidFill>
+                  <a:srgbClr val="111111"/>
+                </a:solidFill>
+                <a:latin typeface="Arial"/>
+              </a:rPr>
+              <a:t>1.   GitHub Public Repository</a:t>
+            </a:r>
+          </a:p>
+          <a:p>
+            <a:pPr algn="l">
+              <a:lnSpc>
+                <a:spcPct val="122000"/>
+              </a:lnSpc>
+              <a:spcAft>
+                <a:spcPts val="1200"/>
+              </a:spcAft>
+            </a:pPr>
+            <a:r>
+              <a:rPr sz="1400" b="0">
+                <a:solidFill>
+                  <a:srgbClr val="333840"/>
+                </a:solidFill>
+                <a:latin typeface="Arial"/>
+              </a:rPr>
+              <a:t>https://github.com/whysush/drishti-crimelink</a:t>
+            </a:r>
+          </a:p>
+          <a:p>
+            <a:pPr algn="l">
+              <a:lnSpc>
+                <a:spcPct val="122000"/>
+              </a:lnSpc>
+              <a:spcAft>
+                <a:spcPts val="300"/>
+              </a:spcAft>
+            </a:pPr>
+            <a:r>
+              <a:rPr sz="1500" b="1">
+                <a:solidFill>
+                  <a:srgbClr val="111111"/>
+                </a:solidFill>
+                <a:latin typeface="Arial"/>
+              </a:rPr>
+              <a:t>2.   Demo Video Link (3 minutes)</a:t>
+            </a:r>
+          </a:p>
+          <a:p>
+            <a:pPr algn="l">
+              <a:lnSpc>
+                <a:spcPct val="122000"/>
+              </a:lnSpc>
+              <a:spcAft>
+                <a:spcPts val="1200"/>
+              </a:spcAft>
+            </a:pPr>
+            <a:r>
+              <a:rPr sz="1300" b="0">
+                <a:solidFill>
+                  <a:srgbClr val="333840"/>
+                </a:solidFill>
+                <a:latin typeface="Arial"/>
+              </a:rPr>
+              <a:t>https://drive.google.com/file/d/1-NFxiHr9veflHYR7-AuijxACmk5u-CWV/view?usp=sharing</a:t>
+            </a:r>
+          </a:p>
+          <a:p>
+            <a:pPr algn="l">
+              <a:lnSpc>
+                <a:spcPct val="122000"/>
+              </a:lnSpc>
+              <a:spcAft>
+                <a:spcPts val="300"/>
+              </a:spcAft>
+            </a:pPr>
+            <a:r>
+              <a:rPr sz="1500" b="1">
+                <a:solidFill>
+                  <a:srgbClr val="111111"/>
+                </a:solidFill>
+                <a:latin typeface="Arial"/>
+              </a:rPr>
+              <a:t>3.   Deployed Link</a:t>
+            </a:r>
+          </a:p>
+          <a:p>
+            <a:pPr algn="l">
+              <a:lnSpc>
+                <a:spcPct val="122000"/>
+              </a:lnSpc>
+              <a:spcAft>
+                <a:spcPts val="1400"/>
+              </a:spcAft>
+            </a:pPr>
+            <a:r>
+              <a:rPr sz="1400" b="0">
+                <a:solidFill>
+                  <a:srgbClr val="333840"/>
+                </a:solidFill>
+                <a:latin typeface="Arial"/>
+              </a:rPr>
+              <a:t>https://crimelink-927199644.development.catalystserverless.com/app/index.html</a:t>
+            </a:r>
+          </a:p>
+          <a:p>
+            <a:pPr algn="l">
+              <a:lnSpc>
+                <a:spcPct val="122000"/>
+              </a:lnSpc>
+              <a:spcAft>
+                <a:spcPts val="500"/>
+              </a:spcAft>
+            </a:pPr>
+            <a:r>
+              <a:rPr sz="1300" b="1">
+                <a:solidFill>
+                  <a:srgbClr val="A8231B"/>
+                </a:solidFill>
+                <a:latin typeface="Arial"/>
+              </a:rPr>
+              <a:t>What is in each</a:t>
+            </a:r>
+          </a:p>
+          <a:p>
+            <a:pPr algn="l">
+              <a:lnSpc>
+                <a:spcPct val="122000"/>
+              </a:lnSpc>
+              <a:spcAft>
+                <a:spcPts val="400"/>
+              </a:spcAft>
+            </a:pPr>
+            <a:r>
+              <a:rPr sz="1250" b="1">
+                <a:solidFill>
+                  <a:srgbClr val="333840"/>
+                </a:solidFill>
+                <a:latin typeface="Arial"/>
+              </a:rPr>
+              <a:t>Repository</a:t>
+            </a:r>
+            <a:r>
+              <a:rPr sz="1250" b="0">
+                <a:solidFill>
+                  <a:srgbClr val="333840"/>
+                </a:solidFill>
+                <a:latin typeface="Arial"/>
+              </a:rPr>
+              <a:t> — the full linkage engine, forecast, triage, person resolution and robustness checks; the API gateway with its access-control layer; the job and event functions; the React client; and the synthetic data generator with its ground truth, so every figure on the previous slide can be reproduced.</a:t>
+            </a:r>
+          </a:p>
+          <a:p>
+            <a:pPr algn="l">
+              <a:lnSpc>
+                <a:spcPct val="122000"/>
+              </a:lnSpc>
+              <a:spcAft>
+                <a:spcPts val="400"/>
+              </a:spcAft>
+            </a:pPr>
+            <a:r>
+              <a:rPr sz="1250" b="1">
+                <a:solidFill>
+                  <a:srgbClr val="333840"/>
+                </a:solidFill>
+                <a:latin typeface="Arial"/>
+              </a:rPr>
+              <a:t>Deployed link</a:t>
+            </a:r>
+            <a:r>
+              <a:rPr sz="1250" b="0">
+                <a:solidFill>
+                  <a:srgbClr val="333840"/>
+                </a:solidFill>
+                <a:latin typeface="Arial"/>
+              </a:rPr>
+              <a:t> — open it a minute or two before viewing. The engine idles between uses and the status bar reads ENGINE LIVE once warm.</a:t>
+            </a:r>
+          </a:p>
+          <a:p>
+            <a:pPr algn="l">
+              <a:lnSpc>
+                <a:spcPct val="122000"/>
+              </a:lnSpc>
+              <a:spcAft>
+                <a:spcPts val="700"/>
+              </a:spcAft>
+            </a:pPr>
+            <a:r>
+              <a:rPr sz="1250" b="1">
+                <a:solidFill>
+                  <a:srgbClr val="333840"/>
+                </a:solidFill>
+                <a:latin typeface="Arial"/>
+              </a:rPr>
+              <a:t>Deep links worth trying</a:t>
+            </a:r>
+            <a:r>
+              <a:rPr sz="1250" b="0">
+                <a:solidFill>
+                  <a:srgbClr val="333840"/>
+                </a:solidFill>
+                <a:latin typeface="Arial"/>
+              </a:rPr>
+              <a:t> — ?tab=model (accuracy and robustness), ?tab=forecast (all projections), ?tab=network (the association graph), ?role=investigator&amp;district=577 (access control), ?lang=kn (Kannada).</a:t>
+            </a:r>
+          </a:p>
+        </p:txBody>
+      </p:sp>
+    </p:spTree>
+  </p:cSld>
+  <p:clrMapOvr>
+    <a:masterClrMapping/>
+  </p:clrMapOvr>
+</p:sld>
+</file>
+
+<file path=ppt/slides/slide17.xml><?xml version="1.0" encoding="utf-8"?>
+<p:sld xmlns:a="http://schemas.openxmlformats.org/drawingml/2006/main" xmlns:p="http://schemas.openxmlformats.org/presentationml/2006/main" xmlns:r="http://schemas.openxmlformats.org/officeDocument/2006/relationships">
+  <p:cSld>
+    <p:spTree>
+      <p:nvGrpSpPr>
+        <p:cNvPr id="1" name=""/>
+        <p:cNvGrpSpPr/>
+        <p:nvPr/>
+      </p:nvGrpSpPr>
+      <p:grpSpPr/>
+      <p:pic>
+        <p:nvPicPr>
+          <p:cNvPr id="2" name="Picture 1" descr="header.png"/>
+          <p:cNvPicPr>
+            <a:picLocks noChangeAspect="1"/>
+          </p:cNvPicPr>
+          <p:nvPr/>
+        </p:nvPicPr>
+        <p:blipFill>
+          <a:blip r:embed="rId2"/>
+          <a:stretch>
+            <a:fillRect/>
+          </a:stretch>
+        </p:blipFill>
+        <p:spPr>
+          <a:xfrm>
+            <a:off x="0" y="0"/>
+            <a:ext cx="12191695" cy="704409"/>
+          </a:xfrm>
+          <a:prstGeom prst="rect">
+            <a:avLst/>
+          </a:prstGeom>
+        </p:spPr>
+      </p:pic>
+      <p:pic>
+        <p:nvPicPr>
+          <p:cNvPr id="3" name="Picture 2" descr="footer.png"/>
+          <p:cNvPicPr>
+            <a:picLocks noChangeAspect="1"/>
+          </p:cNvPicPr>
+          <p:nvPr/>
+        </p:nvPicPr>
+        <p:blipFill>
+          <a:blip r:embed="rId3"/>
+          <a:stretch>
+            <a:fillRect/>
+          </a:stretch>
+        </p:blipFill>
+        <p:spPr>
+          <a:xfrm>
+            <a:off x="0" y="6708990"/>
+            <a:ext cx="12191695" cy="149010"/>
+          </a:xfrm>
+          <a:prstGeom prst="rect">
+            <a:avLst/>
+          </a:prstGeom>
+        </p:spPr>
+      </p:pic>
+      <p:sp>
+        <p:nvSpPr>
+          <p:cNvPr id="4" name="TextBox 3"/>
+          <p:cNvSpPr txBox="1"/>
+          <p:nvPr/>
+        </p:nvSpPr>
+        <p:spPr>
+          <a:xfrm>
+            <a:off x="384048" y="905577"/>
+            <a:ext cx="11368735" cy="548640"/>
+          </a:xfrm>
+          <a:prstGeom prst="rect">
+            <a:avLst/>
+          </a:prstGeom>
+          <a:noFill/>
+        </p:spPr>
+        <p:txBody>
+          <a:bodyPr wrap="square">
+            <a:spAutoFit/>
+          </a:bodyPr>
+          <a:lstStyle/>
+          <a:p>
+            <a:pPr algn="l"/>
+            <a:r>
+              <a:rPr sz="2600" b="1">
+                <a:solidFill>
+                  <a:srgbClr val="111111"/>
+                </a:solidFill>
+                <a:latin typeface="Arial"/>
+              </a:rPr>
+              <a:t>Additional Details / Future Development</a:t>
+            </a:r>
+          </a:p>
+        </p:txBody>
+      </p:sp>
+      <p:sp>
+        <p:nvSpPr>
+          <p:cNvPr id="5" name="TextBox 4"/>
+          <p:cNvSpPr txBox="1"/>
+          <p:nvPr/>
+        </p:nvSpPr>
+        <p:spPr>
+          <a:xfrm>
+            <a:off x="502920" y="1573089"/>
+            <a:ext cx="11185855" cy="4873430"/>
+          </a:xfrm>
+          <a:prstGeom prst="rect">
+            <a:avLst/>
+          </a:prstGeom>
+          <a:noFill/>
+        </p:spPr>
+        <p:txBody>
+          <a:bodyPr wrap="square">
+            <a:spAutoFit/>
+          </a:bodyPr>
+          <a:lstStyle/>
+          <a:p>
+            <a:pPr algn="l">
+              <a:lnSpc>
+                <a:spcPct val="122000"/>
+              </a:lnSpc>
+              <a:spcAft>
+                <a:spcPts val="600"/>
+              </a:spcAft>
+            </a:pPr>
+            <a:r>
+              <a:rPr sz="1300" b="1">
+                <a:solidFill>
+                  <a:srgbClr val="333840"/>
+                </a:solidFill>
+                <a:latin typeface="Arial"/>
+              </a:rPr>
+              <a:t>Go live on real FIR data.</a:t>
+            </a:r>
+            <a:r>
+              <a:rPr sz="1300" b="0">
+                <a:solidFill>
+                  <a:srgbClr val="333840"/>
+                </a:solidFill>
+                <a:latin typeface="Arial"/>
+              </a:rPr>
+              <a:t> The Data Store schema and loader are built and the engine already has a Data Store backend; populating the 28 tables switches the source with no code change, and enables full-text search on BriefFacts.</a:t>
+            </a:r>
+          </a:p>
+          <a:p>
+            <a:pPr algn="l">
+              <a:lnSpc>
+                <a:spcPct val="122000"/>
+              </a:lnSpc>
+              <a:spcAft>
+                <a:spcPts val="600"/>
+              </a:spcAft>
+            </a:pPr>
+            <a:r>
+              <a:rPr sz="1300" b="1">
+                <a:solidFill>
+                  <a:srgbClr val="333840"/>
+                </a:solidFill>
+                <a:latin typeface="Arial"/>
+              </a:rPr>
+              <a:t>Promote to a Production environment.</a:t>
+            </a:r>
+            <a:r>
+              <a:rPr sz="1300" b="0">
+                <a:solidFill>
+                  <a:srgbClr val="333840"/>
+                </a:solidFill>
+                <a:latin typeface="Arial"/>
+              </a:rPr>
+              <a:t> The prototype runs on Catalyst Development.</a:t>
+            </a:r>
+          </a:p>
+          <a:p>
+            <a:pPr algn="l">
+              <a:lnSpc>
+                <a:spcPct val="122000"/>
+              </a:lnSpc>
+              <a:spcAft>
+                <a:spcPts val="600"/>
+              </a:spcAft>
+            </a:pPr>
+            <a:r>
+              <a:rPr sz="1300" b="1">
+                <a:solidFill>
+                  <a:srgbClr val="333840"/>
+                </a:solidFill>
+                <a:latin typeface="Arial"/>
+              </a:rPr>
+              <a:t>Close the loop on the auto-flag.</a:t>
+            </a:r>
+            <a:r>
+              <a:rPr sz="1300" b="0">
+                <a:solidFill>
+                  <a:srgbClr val="333840"/>
+                </a:solidFill>
+                <a:latin typeface="Arial"/>
+              </a:rPr>
+              <a:t> The Signals event function is deployed; binding it to the FIR insert event turns triage from a screen an officer opens into something that happens the moment a case is registered.</a:t>
+            </a:r>
+          </a:p>
+          <a:p>
+            <a:pPr algn="l">
+              <a:lnSpc>
+                <a:spcPct val="122000"/>
+              </a:lnSpc>
+              <a:spcAft>
+                <a:spcPts val="600"/>
+              </a:spcAft>
+            </a:pPr>
+            <a:r>
+              <a:rPr sz="1300" b="1">
+                <a:solidFill>
+                  <a:srgbClr val="333840"/>
+                </a:solidFill>
+                <a:latin typeface="Arial"/>
+              </a:rPr>
+              <a:t>Kannada voice.</a:t>
+            </a:r>
+            <a:r>
+              <a:rPr sz="1300" b="0">
+                <a:solidFill>
+                  <a:srgbClr val="333840"/>
+                </a:solidFill>
+                <a:latin typeface="Arial"/>
+              </a:rPr>
+              <a:t> The interface and the written forecast reports are already bilingual; Zia Services would add speech input and translation of free-text complaints.</a:t>
+            </a:r>
+          </a:p>
+          <a:p>
+            <a:pPr algn="l">
+              <a:lnSpc>
+                <a:spcPct val="122000"/>
+              </a:lnSpc>
+              <a:spcAft>
+                <a:spcPts val="1000"/>
+              </a:spcAft>
+            </a:pPr>
+            <a:r>
+              <a:rPr sz="1300" b="1">
+                <a:solidFill>
+                  <a:srgbClr val="333840"/>
+                </a:solidFill>
+                <a:latin typeface="Arial"/>
+              </a:rPr>
+              <a:t>Learn from investigator feedback.</a:t>
+            </a:r>
+            <a:r>
+              <a:rPr sz="1300" b="0">
+                <a:solidFill>
+                  <a:srgbClr val="333840"/>
+                </a:solidFill>
+                <a:latin typeface="Arial"/>
+              </a:rPr>
+              <a:t> Every group can be marked assigned or dismissed — those judgements are the labels needed to tune signal weights against real outcomes rather than planted ground truth.</a:t>
+            </a:r>
+          </a:p>
+          <a:p>
+            <a:pPr algn="l">
+              <a:lnSpc>
+                <a:spcPct val="122000"/>
+              </a:lnSpc>
+              <a:spcAft>
+                <a:spcPts val="500"/>
+              </a:spcAft>
+            </a:pPr>
+            <a:r>
+              <a:rPr sz="1300" b="1">
+                <a:solidFill>
+                  <a:srgbClr val="A8231B"/>
+                </a:solidFill>
+                <a:latin typeface="Arial"/>
+              </a:rPr>
+              <a:t>Where the method fails — stated on the slide deliberately</a:t>
+            </a:r>
+          </a:p>
+          <a:p>
+            <a:pPr algn="l">
+              <a:lnSpc>
+                <a:spcPct val="122000"/>
+              </a:lnSpc>
+              <a:spcAft>
+                <a:spcPts val="700"/>
+              </a:spcAft>
+            </a:pPr>
+            <a:r>
+              <a:rPr sz="1250" b="0">
+                <a:solidFill>
+                  <a:srgbClr val="333840"/>
+                </a:solidFill>
+                <a:latin typeface="Arial"/>
+              </a:rPr>
+              <a:t>Links are </a:t>
+            </a:r>
+            <a:r>
+              <a:rPr sz="1250" b="1">
+                <a:solidFill>
+                  <a:srgbClr val="333840"/>
+                </a:solidFill>
+                <a:latin typeface="Arial"/>
+              </a:rPr>
+              <a:t>inferred, never asserted</a:t>
+            </a:r>
+            <a:r>
+              <a:rPr sz="1250" b="0">
+                <a:solidFill>
+                  <a:srgbClr val="333840"/>
+                </a:solidFill>
+                <a:latin typeface="Arial"/>
+              </a:rPr>
+              <a:t> — a lead to investigate, not evidence. Two unrelated offenders working the same market at the same hour can look alike. Only 233 of 789 cases name an accused at all, which is why name recurrence is a lead rather than a conclusion. Complainant caste and religion exist in the schema and are </a:t>
+            </a:r>
+            <a:r>
+              <a:rPr sz="1250" b="1">
+                <a:solidFill>
+                  <a:srgbClr val="333840"/>
+                </a:solidFill>
+                <a:latin typeface="Arial"/>
+              </a:rPr>
+              <a:t>never loaded into the engine at all</a:t>
+            </a:r>
+            <a:r>
+              <a:rPr sz="1250" b="0">
+                <a:solidFill>
+                  <a:srgbClr val="333840"/>
+                </a:solidFill>
+                <a:latin typeface="Arial"/>
+              </a:rPr>
+              <a:t>.</a:t>
+            </a:r>
+          </a:p>
+        </p:txBody>
+      </p:sp>
+    </p:spTree>
+  </p:cSld>
+  <p:clrMapOvr>
+    <a:masterClrMapping/>
+  </p:clrMapOvr>
+</p:sld>
+</file>
+
+<file path=ppt/slides/slide18.xml><?xml version="1.0" encoding="utf-8"?>
 <p:sld xmlns:a="http://schemas.openxmlformats.org/drawingml/2006/main" xmlns:p="http://schemas.openxmlformats.org/presentationml/2006/main" xmlns:r="http://schemas.openxmlformats.org/officeDocument/2006/relationships">
   <p:cSld>
     <p:spTree>
@@ -5646,7 +6104,7 @@
                 </a:solidFill>
                 <a:latin typeface="Arial"/>
               </a:rPr>
-              <a:t> — Accused.PersonID is documented as “A1, A2, A3…”, a sort order within a single FIR. When one offender works across several stations, the database holds several unrelated name strings and nobody ever joins them.</a:t>
+              <a:t> — Accused.PersonID is documented as “A1, A2, A3…”, a sort order within a single FIR. When one offender works across several stations the database holds several unrelated name strings, and nobody joins them.</a:t>
             </a:r>
           </a:p>
           <a:p>
@@ -5683,7 +6141,7 @@
                 </a:solidFill>
                 <a:latin typeface="Arial"/>
               </a:rPr>
-              <a:t> from seven signals — the modus operandi in the complaint text, offence type, the Act and Section invoked, location, time-of-day pattern and victim profile. It scores every pair of cases against each other, then groups the look-alikes using </a:t>
+              <a:t> from seven weighted signals — modus operandi text, offence type, the Act and Section invoked, location, time-of-day pattern and victim profile. It scores every pair of cases, then groups the look-alikes using </a:t>
             </a:r>
             <a:r>
               <a:rPr sz="1350" b="1">
@@ -5701,7 +6159,7 @@
                 </a:solidFill>
                 <a:latin typeface="Arial"/>
               </a:rPr>
-              <a:t> on the resulting distance matrix.</a:t>
+              <a:t> on the resulting distance matrix. Each pair's score is discounted by how much evidence was actually available, so thin data makes the engine more cautious rather than louder.</a:t>
             </a:r>
           </a:p>
           <a:p>
@@ -5720,7 +6178,7 @@
                 </a:solidFill>
                 <a:latin typeface="Arial"/>
               </a:rPr>
-              <a:t>The output is not a map of where crime happened. It is a </a:t>
+              <a:t>The output is a </a:t>
             </a:r>
             <a:r>
               <a:rPr sz="1350" b="1">
@@ -5738,7 +6196,7 @@
                 </a:solidFill>
                 <a:latin typeface="Arial"/>
               </a:rPr>
-              <a:t>, each citing the real FIR numbers that make it up, each showing which signals produced the link. From </a:t>
+              <a:t>, each citing real FIR numbers and showing which signals produced the link. From </a:t>
             </a:r>
             <a:r>
               <a:rPr sz="1350" b="1">
@@ -5756,7 +6214,7 @@
                 </a:solidFill>
                 <a:latin typeface="Arial"/>
               </a:rPr>
-              <a:t>, it surfaces </a:t>
+              <a:t> it surfaces </a:t>
             </a:r>
             <a:r>
               <a:rPr sz="1350" b="1">
@@ -5765,7 +6223,16 @@
                 </a:solidFill>
                 <a:latin typeface="Arial"/>
               </a:rPr>
-              <a:t>16 groups holding 87 cases — every one of them spanning more than one police station.</a:t>
+              <a:t>16 groups holding 87 cases — every one spanning more than one police station</a:t>
+            </a:r>
+            <a:r>
+              <a:rPr sz="1350" b="0">
+                <a:solidFill>
+                  <a:srgbClr val="333840"/>
+                </a:solidFill>
+                <a:latin typeface="Arial"/>
+              </a:rPr>
+              <a:t> — then projects where each may strike next.</a:t>
             </a:r>
           </a:p>
         </p:txBody>
@@ -6029,7 +6496,7 @@
                 </a:solidFill>
                 <a:latin typeface="Arial"/>
               </a:rPr>
-              <a:t>→  Explainable evidence trail with measured performance — P 0.928 / R 0.965 / F1 0.946</a:t>
+              <a:t>→  Explainable evidence trail, measured live — P 0.928 / R 0.965 / F1 0.946</a:t>
             </a:r>
           </a:p>
           <a:p>
@@ -6057,7 +6524,7 @@
                 </a:solidFill>
                 <a:latin typeface="Arial"/>
               </a:rPr>
-              <a:t>→  Degrades gracefully — weights renormalise onto typology and spatiotemporal signals</a:t>
+              <a:t>→  Degrades safely — weights renormalise and scores are discounted by evidence coverage</a:t>
             </a:r>
           </a:p>
           <a:p>
@@ -6117,16 +6584,16 @@
               </a:spcAft>
             </a:pPr>
             <a:r>
-              <a:rPr sz="1300" b="0">
-                <a:solidFill>
-                  <a:srgbClr val="333840"/>
-                </a:solidFill>
-                <a:latin typeface="Arial"/>
-              </a:rPr>
-              <a:t>An investigating officer sees their own station's cases. Nobody is positioned to notice that four robberies in four different stations share a method, an hour and a radius. Drishti runs that comparison statewide and returns a ranked list of groups worth reopening, with the evidence attached so the officer can judge it rather than trust it. It then closes the loop forward: a newly registered FIR is scored against every known group as it lands, so a case joins a pattern </a:t>
-            </a:r>
-            <a:r>
-              <a:rPr sz="1300" b="1">
+              <a:rPr sz="1250" b="0">
+                <a:solidFill>
+                  <a:srgbClr val="333840"/>
+                </a:solidFill>
+                <a:latin typeface="Arial"/>
+              </a:rPr>
+              <a:t>An investigating officer sees their own station's cases. Nobody is positioned to notice that four robberies in four different stations share a method, an hour and a radius. Drishti runs that comparison statewide, with the evidence attached — then closes the loop forward, scoring each newly registered FIR against every known group as it lands, so a case joins a pattern </a:t>
+            </a:r>
+            <a:r>
+              <a:rPr sz="1250" b="1">
                 <a:solidFill>
                   <a:srgbClr val="333840"/>
                 </a:solidFill>
@@ -6135,7 +6602,7 @@
               <a:t>before</a:t>
             </a:r>
             <a:r>
-              <a:rPr sz="1300" b="0">
+              <a:rPr sz="1250" b="0">
                 <a:solidFill>
                   <a:srgbClr val="333840"/>
                 </a:solidFill>
@@ -6173,7 +6640,7 @@
               </a:spcAft>
             </a:pPr>
             <a:r>
-              <a:rPr sz="1300" b="1">
+              <a:rPr sz="1200" b="1">
                 <a:solidFill>
                   <a:srgbClr val="333840"/>
                 </a:solidFill>
@@ -6182,7 +6649,7 @@
               <a:t>Works without an offender ID</a:t>
             </a:r>
             <a:r>
-              <a:rPr sz="1300" b="0">
+              <a:rPr sz="1200" b="0">
                 <a:solidFill>
                   <a:srgbClr val="333840"/>
                 </a:solidFill>
@@ -6201,7 +6668,7 @@
               </a:spcAft>
             </a:pPr>
             <a:r>
-              <a:rPr sz="1300" b="1">
+              <a:rPr sz="1200" b="1">
                 <a:solidFill>
                   <a:srgbClr val="333840"/>
                 </a:solidFill>
@@ -6210,7 +6677,7 @@
               <a:t>Every claim is evidence-backed</a:t>
             </a:r>
             <a:r>
-              <a:rPr sz="1300" b="0">
+              <a:rPr sz="1200" b="0">
                 <a:solidFill>
                   <a:srgbClr val="333840"/>
                 </a:solidFill>
@@ -6229,22 +6696,40 @@
               </a:spcAft>
             </a:pPr>
             <a:r>
-              <a:rPr sz="1300" b="1">
-                <a:solidFill>
-                  <a:srgbClr val="333840"/>
-                </a:solidFill>
-                <a:latin typeface="Arial"/>
-              </a:rPr>
-              <a:t>Accuracy measured inside the product</a:t>
-            </a:r>
-            <a:r>
-              <a:rPr sz="1300" b="0">
-                <a:solidFill>
-                  <a:srgbClr val="333840"/>
-                </a:solidFill>
-                <a:latin typeface="Arial"/>
-              </a:rPr>
-              <a:t> — precision 0.928, recall 0.965, F1 0.946, computed live by the same engine that serves the app.</a:t>
+              <a:rPr sz="1200" b="1">
+                <a:solidFill>
+                  <a:srgbClr val="333840"/>
+                </a:solidFill>
+                <a:latin typeface="Arial"/>
+              </a:rPr>
+              <a:t>It does not invent patterns.</a:t>
+            </a:r>
+            <a:r>
+              <a:rPr sz="1200" b="0">
+                <a:solidFill>
+                  <a:srgbClr val="333840"/>
+                </a:solidFill>
+                <a:latin typeface="Arial"/>
+              </a:rPr>
+              <a:t> Scramble the data so nothing is there and it returns </a:t>
+            </a:r>
+            <a:r>
+              <a:rPr sz="1200" b="1">
+                <a:solidFill>
+                  <a:srgbClr val="333840"/>
+                </a:solidFill>
+                <a:latin typeface="Arial"/>
+              </a:rPr>
+              <a:t>zero groups, on every run</a:t>
+            </a:r>
+            <a:r>
+              <a:rPr sz="1200" b="0">
+                <a:solidFill>
+                  <a:srgbClr val="333840"/>
+                </a:solidFill>
+                <a:latin typeface="Arial"/>
+              </a:rPr>
+              <a:t> — shown live in the product.</a:t>
             </a:r>
           </a:p>
           <a:p>
@@ -6257,22 +6742,22 @@
               </a:spcAft>
             </a:pPr>
             <a:r>
-              <a:rPr sz="1300" b="1">
-                <a:solidFill>
-                  <a:srgbClr val="333840"/>
-                </a:solidFill>
-                <a:latin typeface="Arial"/>
-              </a:rPr>
-              <a:t>Identity carries zero weight, and we proved that was right</a:t>
-            </a:r>
-            <a:r>
-              <a:rPr sz="1300" b="0">
-                <a:solidFill>
-                  <a:srgbClr val="333840"/>
-                </a:solidFill>
-                <a:latin typeface="Arial"/>
-              </a:rPr>
-              <a:t> — letting the accused name influence linkage made the engine measurably worse, so we removed it.</a:t>
+              <a:rPr sz="1200" b="1">
+                <a:solidFill>
+                  <a:srgbClr val="333840"/>
+                </a:solidFill>
+                <a:latin typeface="Arial"/>
+              </a:rPr>
+              <a:t>Identity carries zero weight, and we proved it should</a:t>
+            </a:r>
+            <a:r>
+              <a:rPr sz="1200" b="0">
+                <a:solidFill>
+                  <a:srgbClr val="333840"/>
+                </a:solidFill>
+                <a:latin typeface="Arial"/>
+              </a:rPr>
+              <a:t> — letting the accused name influence linkage made the engine measurably worse.</a:t>
             </a:r>
           </a:p>
           <a:p>
@@ -6285,22 +6770,22 @@
               </a:spcAft>
             </a:pPr>
             <a:r>
-              <a:rPr sz="1300" b="1">
-                <a:solidFill>
-                  <a:srgbClr val="333840"/>
-                </a:solidFill>
-                <a:latin typeface="Arial"/>
-              </a:rPr>
-              <a:t>Moves from detection to prevention</a:t>
-            </a:r>
-            <a:r>
-              <a:rPr sz="1300" b="0">
-                <a:solidFill>
-                  <a:srgbClr val="333840"/>
-                </a:solidFill>
-                <a:latin typeface="Arial"/>
-              </a:rPr>
-              <a:t> — a projected window and area for each group's next offence, back-tested at 92.9% on area.</a:t>
+              <a:rPr sz="1200" b="1">
+                <a:solidFill>
+                  <a:srgbClr val="333840"/>
+                </a:solidFill>
+                <a:latin typeface="Arial"/>
+              </a:rPr>
+              <a:t>Detection becomes prevention</a:t>
+            </a:r>
+            <a:r>
+              <a:rPr sz="1200" b="0">
+                <a:solidFill>
+                  <a:srgbClr val="333840"/>
+                </a:solidFill>
+                <a:latin typeface="Arial"/>
+              </a:rPr>
+              <a:t> — a projected window and area for each group's next offence, back-tested at 92.9% on area, written out in plain language.</a:t>
             </a:r>
           </a:p>
         </p:txBody>
@@ -6452,7 +6937,7 @@
                 </a:solidFill>
                 <a:latin typeface="Arial"/>
               </a:rPr>
-              <a:t> — behavioural fingerprint over seven weighted signals, composite pairwise similarity, agglomerative clustering into ranked offender groups</a:t>
+              <a:t> — behavioural fingerprint over seven weighted signals, composite pairwise similarity discounted by evidence coverage, agglomerative clustering into ranked offender groups</a:t>
             </a:r>
           </a:p>
           <a:p>
@@ -6480,7 +6965,7 @@
                 </a:solidFill>
                 <a:latin typeface="Arial"/>
               </a:rPr>
-              <a:t> — per-signal contribution breakdown, cited FIR numbers, spatial span and a full case timeline</a:t>
+              <a:t> — per-signal contribution, cited FIR numbers, spatial span and a full case timeline</a:t>
             </a:r>
           </a:p>
           <a:p>
@@ -6499,7 +6984,7 @@
                 </a:solidFill>
                 <a:latin typeface="Arial"/>
               </a:rPr>
-              <a:t>Next-strike projection</a:t>
+              <a:t>Forecast — its own workspace</a:t>
             </a:r>
             <a:r>
               <a:rPr sz="1250" b="0">
@@ -6508,7 +6993,7 @@
                 </a:solidFill>
                 <a:latin typeface="Arial"/>
               </a:rPr>
-              <a:t> — time window, area radius and usual hours from the group's median inter-event gap and 90th-percentile spread, with a stated confidence</a:t>
+              <a:t> — every group's projected window, area radius and usual hours, ranked with open windows first and written out as a plain-language report</a:t>
             </a:r>
           </a:p>
           <a:p>
@@ -6536,7 +7021,7 @@
                 </a:solidFill>
                 <a:latin typeface="Arial"/>
               </a:rPr>
-              <a:t> — an incoming case scored against every known group and graded against that group's own cohesion — Escalate, Review, or treat as unlinked</a:t>
+              <a:t> — an incoming case scored against every known group, graded against that group's own cohesion — Escalate, Review, or treat as unlinked</a:t>
             </a:r>
           </a:p>
           <a:p>
@@ -6555,7 +7040,7 @@
                 </a:solidFill>
                 <a:latin typeface="Arial"/>
               </a:rPr>
-              <a:t>Persons of interest</a:t>
+              <a:t>Association network</a:t>
             </a:r>
             <a:r>
               <a:rPr sz="1250" b="0">
@@ -6564,7 +7049,7 @@
                 </a:solidFill>
                 <a:latin typeface="Arial"/>
               </a:rPr>
-              <a:t> — cross-FIR name resolution with fuzzy matching for transliteration drift</a:t>
+              <a:t> — 25 people who never share an FIR, linked by shared modus operandi in overlapping jurisdictions; click one and their whole crime history draws on the map in date order</a:t>
             </a:r>
           </a:p>
           <a:p>
@@ -6592,7 +7077,7 @@
                 </a:solidFill>
                 <a:latin typeface="Arial"/>
               </a:rPr>
-              <a:t> — WebGL terrain extruded from real district boundaries, with case pins, linked-group webs and the projected zone</a:t>
+              <a:t> — districts extruded from real boundaries, with case pins, link webs, forecast rings and red/yellow risk zones</a:t>
             </a:r>
           </a:p>
           <a:p>
@@ -6611,7 +7096,7 @@
                 </a:solidFill>
                 <a:latin typeface="Arial"/>
               </a:rPr>
-              <a:t>Natural-language search</a:t>
+              <a:t>Robustness shown in-product</a:t>
             </a:r>
             <a:r>
               <a:rPr sz="1250" b="0">
@@ -6620,7 +7105,7 @@
                 </a:solidFill>
                 <a:latin typeface="Arial"/>
               </a:rPr>
-              <a:t> — retrieval-only, so every answer cites real records and cannot fabricate</a:t>
+              <a:t> — negative control and graceful-degradation results, recomputed live alongside accuracy</a:t>
             </a:r>
           </a:p>
           <a:p>
@@ -6676,7 +7161,7 @@
                 </a:solidFill>
                 <a:latin typeface="Arial"/>
               </a:rPr>
-              <a:t> — investigator, analyst and supervisor, enforced at the API gateway; investigators scoped to their district</a:t>
+              <a:t> — investigator, analyst and supervisor, enforced at the API gateway; investigators scoped to their own district</a:t>
             </a:r>
           </a:p>
           <a:p>
@@ -6695,7 +7180,7 @@
                 </a:solidFill>
                 <a:latin typeface="Arial"/>
               </a:rPr>
-              <a:t>In-product accuracy panel</a:t>
+              <a:t>Natural-language search</a:t>
             </a:r>
             <a:r>
               <a:rPr sz="1250" b="0">
@@ -6704,7 +7189,7 @@
                 </a:solidFill>
                 <a:latin typeface="Arial"/>
               </a:rPr>
-              <a:t> — precision, recall, F1, per-signal ablation and a written statement of where the method fails</a:t>
+              <a:t> — retrieval-only, so every answer cites real records and cannot fabricate</a:t>
             </a:r>
           </a:p>
           <a:p>
@@ -6732,7 +7217,7 @@
                 </a:solidFill>
                 <a:latin typeface="Arial"/>
               </a:rPr>
-              <a:t> — English and Kannada across all labels and explanations</a:t>
+              <a:t> — English and Kannada across all labels, explanations and the written forecast reports</a:t>
             </a:r>
           </a:p>
         </p:txBody>
@@ -6927,7 +7412,7 @@
                 </a:solidFill>
                 <a:latin typeface="Arial"/>
               </a:rPr>
-              <a:t> — every undetected FIR is fingerprinted on seven weighted signals, scored against every other case, and clustered. Groups are then ranked by cohesion multiplied by actionability, which favours jurisdictional reach, recency and gravity. Runs nightly.</a:t>
+              <a:t> — every undetected FIR is fingerprinted on seven weighted signals, scored against every other case, and clustered. Groups are ranked by cohesion multiplied by actionability, favouring jurisdictional reach, recency and gravity. Runs nightly.</a:t>
             </a:r>
           </a:p>
           <a:p>
@@ -6955,7 +7440,7 @@
                 </a:solidFill>
                 <a:latin typeface="Arial"/>
               </a:rPr>
-              <a:t> — a newly registered FIR is fingerprinted identically and scored against each group, then graded against that group's own internal cohesion rather than a fixed threshold. A tight group demands a high score; a loose one cannot reach it.</a:t>
+              <a:t> — a newly registered FIR is fingerprinted identically and scored against each group, graded against that group's own internal cohesion rather than a fixed threshold.</a:t>
             </a:r>
           </a:p>
           <a:p>
@@ -6983,7 +7468,7 @@
                 </a:solidFill>
                 <a:latin typeface="Arial"/>
               </a:rPr>
-              <a:t> Each group carries the per-signal contributions that produced it and the real FIR numbers it cites, so an investigator can audit the reasoning rather than trust the output.</a:t>
+              <a:t> Each group carries the per-signal contributions that produced it and the real FIR numbers it cites, so an investigator can audit the reasoning.</a:t>
             </a:r>
           </a:p>
         </p:txBody>
@@ -7150,7 +7635,7 @@
                 </a:solidFill>
                 <a:latin typeface="Arial"/>
               </a:rPr>
-              <a:t>Three regions, each doing one job: navigation on the rail, the map as the workspace, and the dossier where a lead opens into a full case file with its evidence. Live screens of this layout follow on the next slides.</a:t>
+              <a:t>Three regions, each doing one job: navigation on the rail, the map as the workspace, and the dossier where a lead opens into a full case file with its evidence. Live screens of this layout follow.</a:t>
             </a:r>
           </a:p>
         </p:txBody>
@@ -7482,7 +7967,7 @@
           <a:p>
             <a:pPr algn="l"/>
             <a:r>
-              <a:rPr sz="1300">
+              <a:rPr sz="1300" b="0">
                 <a:solidFill>
                   <a:srgbClr val="333840"/>
                 </a:solidFill>
@@ -7552,7 +8037,7 @@
           <a:p>
             <a:pPr algn="l"/>
             <a:r>
-              <a:rPr sz="1300">
+              <a:rPr sz="1300" b="0">
                 <a:solidFill>
                   <a:srgbClr val="333840"/>
                 </a:solidFill>
@@ -7622,7 +8107,7 @@
           <a:p>
             <a:pPr algn="l"/>
             <a:r>
-              <a:rPr sz="1300">
+              <a:rPr sz="1300" b="0">
                 <a:solidFill>
                   <a:srgbClr val="333840"/>
                 </a:solidFill>
@@ -7692,7 +8177,7 @@
           <a:p>
             <a:pPr algn="l"/>
             <a:r>
-              <a:rPr sz="1300">
+              <a:rPr sz="1300" b="0">
                 <a:solidFill>
                   <a:srgbClr val="333840"/>
                 </a:solidFill>
@@ -7762,7 +8247,7 @@
           <a:p>
             <a:pPr algn="l"/>
             <a:r>
-              <a:rPr sz="1300">
+              <a:rPr sz="1300" b="0">
                 <a:solidFill>
                   <a:srgbClr val="333840"/>
                 </a:solidFill>
@@ -7832,7 +8317,7 @@
           <a:p>
             <a:pPr algn="l"/>
             <a:r>
-              <a:rPr sz="1300">
+              <a:rPr sz="1300" b="0">
                 <a:solidFill>
                   <a:srgbClr val="333840"/>
                 </a:solidFill>
@@ -7899,7 +8384,7 @@
                 </a:solidFill>
                 <a:latin typeface="Arial"/>
               </a:rPr>
-              <a:t>Behavioural fingerprinting · TF-IDF over complaint text · weighted composite similarity with per-pair weight renormalisation · agglomerative clustering on a precomputed distance matrix · leave-one-signal-out ablation · hold-one-out forecast back-testing · Douglas-Peucker simplification for the district meshes.</a:t>
+              <a:t>Behavioural fingerprinting · TF-IDF over complaint text · weighted composite similarity with per-pair renormalisation and an evidence-coverage discount · agglomerative clustering on a precomputed distance matrix · leave-one-signal-out ablation · hold-one-out forecast back-testing · permutation-based negative control · Douglas-Peucker simplification for the district meshes.</a:t>
             </a:r>
           </a:p>
           <a:p>
@@ -7955,7 +8440,7 @@
                 </a:solidFill>
                 <a:latin typeface="Arial"/>
               </a:rPr>
-              <a:t> on purpose, so the whole engine installs from requirements.txt on the Catalyst managed runtime with </a:t>
+              <a:t>, so the engine installs from requirements.txt on the Catalyst managed runtime with </a:t>
             </a:r>
             <a:r>
               <a:rPr sz="1250" b="1">
@@ -8194,13 +8679,13 @@
           <a:p>
             <a:pPr algn="l"/>
             <a:r>
-              <a:rPr sz="1250">
-                <a:solidFill>
-                  <a:srgbClr val="333840"/>
-                </a:solidFill>
-                <a:latin typeface="Arial"/>
-              </a:rPr>
-              <a:t>Hosts the ML engine — fingerprinting, clustering, forecast, triage, PDF</a:t>
+              <a:rPr sz="1250" b="0">
+                <a:solidFill>
+                  <a:srgbClr val="333840"/>
+                </a:solidFill>
+                <a:latin typeface="Arial"/>
+              </a:rPr>
+              <a:t>Hosts the ML engine — fingerprinting, clustering, forecast, triage, robustness, PDF</a:t>
             </a:r>
           </a:p>
         </p:txBody>
@@ -8264,7 +8749,7 @@
           <a:p>
             <a:pPr algn="l"/>
             <a:r>
-              <a:rPr sz="1250">
+              <a:rPr sz="1250" b="0">
                 <a:solidFill>
                   <a:srgbClr val="333840"/>
                 </a:solidFill>
@@ -8334,7 +8819,7 @@
           <a:p>
             <a:pPr algn="l"/>
             <a:r>
-              <a:rPr sz="1250">
+              <a:rPr sz="1250" b="0">
                 <a:solidFill>
                   <a:srgbClr val="333840"/>
                 </a:solidFill>
@@ -8404,7 +8889,7 @@
           <a:p>
             <a:pPr algn="l"/>
             <a:r>
-              <a:rPr sz="1250">
+              <a:rPr sz="1250" b="0">
                 <a:solidFill>
                   <a:srgbClr val="333840"/>
                 </a:solidFill>
@@ -8474,7 +8959,7 @@
           <a:p>
             <a:pPr algn="l"/>
             <a:r>
-              <a:rPr sz="1250">
+              <a:rPr sz="1250" b="0">
                 <a:solidFill>
                   <a:srgbClr val="333840"/>
                 </a:solidFill>
@@ -8544,7 +9029,7 @@
           <a:p>
             <a:pPr algn="l"/>
             <a:r>
-              <a:rPr sz="1250">
+              <a:rPr sz="1250" b="0">
                 <a:solidFill>
                   <a:srgbClr val="333840"/>
                 </a:solidFill>
@@ -8614,7 +9099,7 @@
           <a:p>
             <a:pPr algn="l"/>
             <a:r>
-              <a:rPr sz="1250">
+              <a:rPr sz="1250" b="0">
                 <a:solidFill>
                   <a:srgbClr val="333840"/>
                 </a:solidFill>
@@ -8684,7 +9169,7 @@
           <a:p>
             <a:pPr algn="l"/>
             <a:r>
-              <a:rPr sz="1250">
+              <a:rPr sz="1250" b="0">
                 <a:solidFill>
                   <a:srgbClr val="333840"/>
                 </a:solidFill>
@@ -8754,7 +9239,7 @@
           <a:p>
             <a:pPr algn="l"/>
             <a:r>
-              <a:rPr sz="1250">
+              <a:rPr sz="1250" b="0">
                 <a:solidFill>
                   <a:srgbClr val="333840"/>
                 </a:solidFill>

</xml_diff>